<commit_message>
Report approved scheme pilots and refresh research evidence package
</commit_message>
<xml_diff>
--- a/reports/slides/research_review.pptx
+++ b/reports/slides/research_review.pptx
@@ -522,6 +522,11 @@
               <a:t>Configuration: configs/attacks/fei_key_pool_boundary.yaml. See reports/figures/README.md for figure captions and docs/ROADMAP.md for pending gates. Diagram symbols are schematic, not biometric examples.</a:t>
             </a:r>
           </a:p>
+          <a:p>
+            <a:r>
+              <a:t>New pilot code freeze: d5f4e89. Configuration: configs/attacks/scheme_extension_pilot.yaml. Sources: experiments/scheme_extension_pilot/{results_summary,paired_uncertainty,equivalence_sensitivity,native_utility}.csv. One-seed CPU pilots, 120-epoch cap; not a controlled ranking against earlier 400-epoch, three-seed studies. See figure_appendix.pdf for all figures, including native matching and uncertainty.</a:t>
+            </a:r>
+          </a:p>
         </p:txBody>
       </p:sp>
       <p:sp>
@@ -602,6 +607,11 @@
               <a:t>Configuration: configs/attacks/fei_key_pool_boundary.yaml. See reports/figures/README.md for figure captions and docs/ROADMAP.md for pending gates. Diagram symbols are schematic, not biometric examples.</a:t>
             </a:r>
           </a:p>
+          <a:p>
+            <a:r>
+              <a:t>New pilot code freeze: d5f4e89. Configuration: configs/attacks/scheme_extension_pilot.yaml. Sources: experiments/scheme_extension_pilot/{results_summary,paired_uncertainty,equivalence_sensitivity,native_utility}.csv. One-seed CPU pilots, 120-epoch cap; not a controlled ranking against earlier 400-epoch, three-seed studies. See figure_appendix.pdf for all figures, including native matching and uncertainty.</a:t>
+            </a:r>
+          </a:p>
         </p:txBody>
       </p:sp>
       <p:sp>
@@ -682,6 +692,11 @@
               <a:t>Configuration: configs/attacks/fei_key_pool_boundary.yaml. See reports/figures/README.md for figure captions and docs/ROADMAP.md for pending gates. Diagram symbols are schematic, not biometric examples.</a:t>
             </a:r>
           </a:p>
+          <a:p>
+            <a:r>
+              <a:t>New pilot code freeze: d5f4e89. Configuration: configs/attacks/scheme_extension_pilot.yaml. Sources: experiments/scheme_extension_pilot/{results_summary,paired_uncertainty,equivalence_sensitivity,native_utility}.csv. One-seed CPU pilots, 120-epoch cap; not a controlled ranking against earlier 400-epoch, three-seed studies. See figure_appendix.pdf for all figures, including native matching and uncertainty.</a:t>
+            </a:r>
+          </a:p>
         </p:txBody>
       </p:sp>
       <p:sp>
@@ -762,6 +777,11 @@
               <a:t>Configuration: configs/attacks/fei_key_pool_boundary.yaml. See reports/figures/README.md for figure captions and docs/ROADMAP.md for pending gates. Diagram symbols are schematic, not biometric examples.</a:t>
             </a:r>
           </a:p>
+          <a:p>
+            <a:r>
+              <a:t>New pilot code freeze: d5f4e89. Configuration: configs/attacks/scheme_extension_pilot.yaml. Sources: experiments/scheme_extension_pilot/{results_summary,paired_uncertainty,equivalence_sensitivity,native_utility}.csv. One-seed CPU pilots, 120-epoch cap; not a controlled ranking against earlier 400-epoch, three-seed studies. See figure_appendix.pdf for all figures, including native matching and uncertainty.</a:t>
+            </a:r>
+          </a:p>
         </p:txBody>
       </p:sp>
       <p:sp>
@@ -842,6 +862,11 @@
               <a:t>Configuration: configs/attacks/fei_key_pool_boundary.yaml. See reports/figures/README.md for figure captions and docs/ROADMAP.md for pending gates. Diagram symbols are schematic, not biometric examples.</a:t>
             </a:r>
           </a:p>
+          <a:p>
+            <a:r>
+              <a:t>New pilot code freeze: d5f4e89. Configuration: configs/attacks/scheme_extension_pilot.yaml. Sources: experiments/scheme_extension_pilot/{results_summary,paired_uncertainty,equivalence_sensitivity,native_utility}.csv. One-seed CPU pilots, 120-epoch cap; not a controlled ranking against earlier 400-epoch, three-seed studies. See figure_appendix.pdf for all figures, including native matching and uncertainty.</a:t>
+            </a:r>
+          </a:p>
         </p:txBody>
       </p:sp>
       <p:sp>
@@ -922,6 +947,11 @@
               <a:t>Configuration: configs/attacks/fei_key_pool_boundary.yaml. See reports/figures/README.md for figure captions and docs/ROADMAP.md for pending gates. Diagram symbols are schematic, not biometric examples.</a:t>
             </a:r>
           </a:p>
+          <a:p>
+            <a:r>
+              <a:t>New pilot code freeze: d5f4e89. Configuration: configs/attacks/scheme_extension_pilot.yaml. Sources: experiments/scheme_extension_pilot/{results_summary,paired_uncertainty,equivalence_sensitivity,native_utility}.csv. One-seed CPU pilots, 120-epoch cap; not a controlled ranking against earlier 400-epoch, three-seed studies. See figure_appendix.pdf for all figures, including native matching and uncertainty.</a:t>
+            </a:r>
+          </a:p>
         </p:txBody>
       </p:sp>
       <p:sp>
@@ -1002,6 +1032,11 @@
               <a:t>Configuration: configs/attacks/fei_key_pool_boundary.yaml. See reports/figures/README.md for figure captions and docs/ROADMAP.md for pending gates. Diagram symbols are schematic, not biometric examples.</a:t>
             </a:r>
           </a:p>
+          <a:p>
+            <a:r>
+              <a:t>New pilot code freeze: d5f4e89. Configuration: configs/attacks/scheme_extension_pilot.yaml. Sources: experiments/scheme_extension_pilot/{results_summary,paired_uncertainty,equivalence_sensitivity,native_utility}.csv. One-seed CPU pilots, 120-epoch cap; not a controlled ranking against earlier 400-epoch, three-seed studies. See figure_appendix.pdf for all figures, including native matching and uncertainty.</a:t>
+            </a:r>
+          </a:p>
         </p:txBody>
       </p:sp>
       <p:sp>
@@ -1080,6 +1115,11 @@
           <a:p>
             <a:r>
               <a:t>Configuration: configs/attacks/fei_key_pool_boundary.yaml. See reports/figures/README.md for figure captions and docs/ROADMAP.md for pending gates. Diagram symbols are schematic, not biometric examples.</a:t>
+            </a:r>
+          </a:p>
+          <a:p>
+            <a:r>
+              <a:t>New pilot code freeze: d5f4e89. Configuration: configs/attacks/scheme_extension_pilot.yaml. Sources: experiments/scheme_extension_pilot/{results_summary,paired_uncertainty,equivalence_sensitivity,native_utility}.csv. One-seed CPU pilots, 120-epoch cap; not a controlled ranking against earlier 400-epoch, three-seed studies. See figure_appendix.pdf for all figures, including native matching and uncertainty.</a:t>
             </a:r>
           </a:p>
         </p:txBody>
@@ -4248,7 +4288,7 @@
               </a:defRPr>
             </a:pPr>
             <a:r>
-              <a:t>Fresh independent keys: chance-compatible results in the tested attacks.</a:t>
+              <a:t>Fresh-key learned attacks: uncertainty remains; no equivalence claim.</a:t>
             </a:r>
           </a:p>
           <a:p>
@@ -5483,8 +5523,8 @@
         </p:nvSpPr>
         <p:spPr>
           <a:xfrm>
-            <a:off x="548640" y="3977639"/>
-            <a:ext cx="11064240" cy="1463040"/>
+            <a:off x="548640" y="3794760"/>
+            <a:ext cx="11064240" cy="1691640"/>
           </a:xfrm>
           <a:prstGeom prst="rect">
             <a:avLst/>
@@ -5504,7 +5544,7 @@
               <a:spcAft>
                 <a:spcPts val="0"/>
               </a:spcAft>
-              <a:defRPr sz="1700" b="0">
+              <a:defRPr sz="1600" b="0">
                 <a:solidFill>
                   <a:srgbClr val="222222"/>
                 </a:solidFill>
@@ -5512,7 +5552,7 @@
               </a:defRPr>
             </a:pPr>
             <a:r>
-              <a:t>BioHash: 128 bits; all three datasets.</a:t>
+              <a:t>BioHash: 128 bits; three datasets; includes a Haar-sign control on MOBIO.</a:t>
             </a:r>
           </a:p>
           <a:p>
@@ -5523,7 +5563,7 @@
               <a:spcAft>
                 <a:spcPts val="0"/>
               </a:spcAft>
-              <a:defRPr sz="1700" b="0">
+              <a:defRPr sz="1600" b="0">
                 <a:solidFill>
                   <a:srgbClr val="222222"/>
                 </a:solidFill>
@@ -5531,7 +5571,7 @@
               </a:defRPr>
             </a:pPr>
             <a:r>
-              <a:t>MLP-Hash: 512 bits; MOBIO only; paper-specified, not source-exact.</a:t>
+              <a:t>MLP-Hash: 512 bits; MOBIO; paper-specified, not source-exact.</a:t>
             </a:r>
           </a:p>
           <a:p>
@@ -5542,7 +5582,7 @@
               <a:spcAft>
                 <a:spcPts val="0"/>
               </a:spcAft>
-              <a:defRPr sz="1700" b="0">
+              <a:defRPr sz="1600" b="0">
                 <a:solidFill>
                   <a:srgbClr val="222222"/>
                 </a:solidFill>
@@ -5550,7 +5590,26 @@
               </a:defRPr>
             </a:pPr>
             <a:r>
-              <a:t>Haar-sign-corrected BioHash: MOBIO implementation control.</a:t>
+              <a:t>IoM-GRP: 300 categorical codes (q=16); MOBIO/FEI pilots.</a:t>
+            </a:r>
+          </a:p>
+          <a:p>
+            <a:pPr>
+              <a:lnSpc>
+                <a:spcPct val="140000"/>
+              </a:lnSpc>
+              <a:spcAft>
+                <a:spcPts val="0"/>
+              </a:spcAft>
+              <a:defRPr sz="1600" b="0">
+                <a:solidFill>
+                  <a:srgbClr val="222222"/>
+                </a:solidFill>
+                <a:latin typeface="Times New Roman"/>
+              </a:defRPr>
+            </a:pPr>
+            <a:r>
+              <a:t>PolyProtect: 170 real values (m=5, overlap=2); MOBIO/FEI pilots.</a:t>
             </a:r>
           </a:p>
         </p:txBody>
@@ -5820,7 +5879,7 @@
               </a:defRPr>
             </a:pPr>
             <a:r>
-              <a:t>All completed key-pool studies</a:t>
+              <a:t>Earlier three-seed key-pool studies</a:t>
             </a:r>
           </a:p>
         </p:txBody>
@@ -5928,7 +5987,7 @@
               </a:defRPr>
             </a:pPr>
             <a:r>
-              <a:t>65 conditions from 11 studies. Missing endpoints stay blank; interval failures remain visible.</a:t>
+              <a:t>65 conditions from 11 earlier studies. New one-seed pilots are reported separately.</a:t>
             </a:r>
           </a:p>
         </p:txBody>
@@ -6156,7 +6215,7 @@
               </a:defRPr>
             </a:pPr>
             <a:r>
-              <a:t>Fresh-key endpoints across datasets</a:t>
+              <a:t>Approved scheme pilots: one seed</a:t>
             </a:r>
           </a:p>
         </p:txBody>
@@ -6205,7 +6264,7 @@
       </p:sp>
       <p:pic>
         <p:nvPicPr>
-          <p:cNvPr id="4" name="Picture 3" descr="fig_fresh_exposures.png"/>
+          <p:cNvPr id="4" name="Picture 3" descr="fig_scheme_pilots.png"/>
           <p:cNvPicPr>
             <a:picLocks noChangeAspect="1"/>
           </p:cNvPicPr>
@@ -6219,8 +6278,8 @@
         </p:blipFill>
         <p:spPr>
           <a:xfrm>
-            <a:off x="365760" y="1296296"/>
-            <a:ext cx="5577840" cy="4265407"/>
+            <a:off x="2935877" y="960120"/>
+            <a:ext cx="6289765" cy="4892040"/>
           </a:xfrm>
           <a:prstGeom prst="rect">
             <a:avLst/>
@@ -6235,8 +6294,8 @@
         </p:nvSpPr>
         <p:spPr>
           <a:xfrm>
-            <a:off x="6217920" y="1645920"/>
-            <a:ext cx="5394960" cy="3108960"/>
+            <a:off x="548640" y="6016752"/>
+            <a:ext cx="11064240" cy="365760"/>
           </a:xfrm>
           <a:prstGeom prst="rect">
             <a:avLst/>
@@ -6256,7 +6315,7 @@
               <a:spcAft>
                 <a:spcPts val="0"/>
               </a:spcAft>
-              <a:defRPr sz="1500" b="0">
+              <a:defRPr sz="1200" b="0">
                 <a:solidFill>
                   <a:srgbClr val="222222"/>
                 </a:solidFill>
@@ -6264,173 +6323,7 @@
               </a:defRPr>
             </a:pPr>
             <a:r>
-              <a:t>BioHash, 10-record mean-pool endpoint:</a:t>
-            </a:r>
-          </a:p>
-          <a:p>
-            <a:pPr>
-              <a:lnSpc>
-                <a:spcPct val="140000"/>
-              </a:lnSpc>
-              <a:spcAft>
-                <a:spcPts val="0"/>
-              </a:spcAft>
-              <a:defRPr sz="1500" b="0">
-                <a:solidFill>
-                  <a:srgbClr val="222222"/>
-                </a:solidFill>
-                <a:latin typeface="Times New Roman"/>
-              </a:defRPr>
-            </a:pPr>
-          </a:p>
-          <a:p>
-            <a:pPr>
-              <a:lnSpc>
-                <a:spcPct val="140000"/>
-              </a:lnSpc>
-              <a:spcAft>
-                <a:spcPts val="0"/>
-              </a:spcAft>
-              <a:defRPr sz="1500" b="0">
-                <a:solidFill>
-                  <a:srgbClr val="222222"/>
-                </a:solidFill>
-                <a:latin typeface="Times New Roman"/>
-              </a:defRPr>
-            </a:pPr>
-            <a:r>
-              <a:t>MOBIO: 3.61% (chance 3.33%)</a:t>
-            </a:r>
-          </a:p>
-          <a:p>
-            <a:pPr>
-              <a:lnSpc>
-                <a:spcPct val="140000"/>
-              </a:lnSpc>
-              <a:spcAft>
-                <a:spcPts val="0"/>
-              </a:spcAft>
-              <a:defRPr sz="1500" b="0">
-                <a:solidFill>
-                  <a:srgbClr val="222222"/>
-                </a:solidFill>
-                <a:latin typeface="Times New Roman"/>
-              </a:defRPr>
-            </a:pPr>
-          </a:p>
-          <a:p>
-            <a:pPr>
-              <a:lnSpc>
-                <a:spcPct val="140000"/>
-              </a:lnSpc>
-              <a:spcAft>
-                <a:spcPts val="0"/>
-              </a:spcAft>
-              <a:defRPr sz="1500" b="0">
-                <a:solidFill>
-                  <a:srgbClr val="222222"/>
-                </a:solidFill>
-                <a:latin typeface="Times New Roman"/>
-              </a:defRPr>
-            </a:pPr>
-            <a:r>
-              <a:t>LFW: 4.00% (chance 4.00%)</a:t>
-            </a:r>
-          </a:p>
-          <a:p>
-            <a:pPr>
-              <a:lnSpc>
-                <a:spcPct val="140000"/>
-              </a:lnSpc>
-              <a:spcAft>
-                <a:spcPts val="0"/>
-              </a:spcAft>
-              <a:defRPr sz="1500" b="0">
-                <a:solidFill>
-                  <a:srgbClr val="222222"/>
-                </a:solidFill>
-                <a:latin typeface="Times New Roman"/>
-              </a:defRPr>
-            </a:pPr>
-          </a:p>
-          <a:p>
-            <a:pPr>
-              <a:lnSpc>
-                <a:spcPct val="140000"/>
-              </a:lnSpc>
-              <a:spcAft>
-                <a:spcPts val="0"/>
-              </a:spcAft>
-              <a:defRPr sz="1500" b="0">
-                <a:solidFill>
-                  <a:srgbClr val="222222"/>
-                </a:solidFill>
-                <a:latin typeface="Times New Roman"/>
-              </a:defRPr>
-            </a:pPr>
-            <a:r>
-              <a:t>FEI: 1.77% (chance 2.50%)</a:t>
-            </a:r>
-          </a:p>
-        </p:txBody>
-      </p:sp>
-      <p:sp>
-        <p:nvSpPr>
-          <p:cNvPr id="6" name="TextBox 5"/>
-          <p:cNvSpPr txBox="1"/>
-          <p:nvPr/>
-        </p:nvSpPr>
-        <p:spPr>
-          <a:xfrm>
-            <a:off x="6217920" y="4937760"/>
-            <a:ext cx="5394960" cy="822960"/>
-          </a:xfrm>
-          <a:prstGeom prst="rect">
-            <a:avLst/>
-          </a:prstGeom>
-          <a:noFill/>
-        </p:spPr>
-        <p:txBody>
-          <a:bodyPr wrap="none" lIns="0" rIns="0" tIns="0" bIns="0">
-            <a:spAutoFit/>
-          </a:bodyPr>
-          <a:lstStyle/>
-          <a:p>
-            <a:pPr>
-              <a:lnSpc>
-                <a:spcPct val="140000"/>
-              </a:lnSpc>
-              <a:spcAft>
-                <a:spcPts val="0"/>
-              </a:spcAft>
-              <a:defRPr sz="1600" b="1">
-                <a:solidFill>
-                  <a:srgbClr val="222222"/>
-                </a:solidFill>
-                <a:latin typeface="Times New Roman"/>
-              </a:defRPr>
-            </a:pPr>
-            <a:r>
-              <a:t>Chance inclusion is not equivalence.</a:t>
-            </a:r>
-          </a:p>
-          <a:p>
-            <a:pPr>
-              <a:lnSpc>
-                <a:spcPct val="140000"/>
-              </a:lnSpc>
-              <a:spcAft>
-                <a:spcPts val="0"/>
-              </a:spcAft>
-              <a:defRPr sz="1600" b="1">
-                <a:solidFill>
-                  <a:srgbClr val="222222"/>
-                </a:solidFill>
-                <a:latin typeface="Times New Roman"/>
-              </a:defRPr>
-            </a:pPr>
-            <a:r>
-              <a:t>No universal privacy guarantee.</a:t>
+              <a:t>Fresh PolyProtect native matching: MOBIO 12.73%, FEI 13.73%; separate task, not a privacy result.</a:t>
             </a:r>
           </a:p>
         </p:txBody>
@@ -6574,7 +6467,7 @@
               </a:defRPr>
             </a:pPr>
             <a:r>
-              <a:t>Completed: three datasets, two schemes on MOBIO, reuse and mechanism controls.</a:t>
+              <a:t>Completed: two new schemes, 16 pilot cells, paired intervals, per-seed results.</a:t>
             </a:r>
           </a:p>
         </p:txBody>
@@ -6635,7 +6528,7 @@
               </a:defRPr>
             </a:pPr>
             <a:r>
-              <a:t>1. Approve and obtain the next dataset; approve two additional schemes.</a:t>
+              <a:t>1. Obtain authorized access to the next dataset.</a:t>
             </a:r>
           </a:p>
           <a:p>
@@ -6654,7 +6547,7 @@
               </a:defRPr>
             </a:pPr>
             <a:r>
-              <a:t>2. Freeze the extension protocol, then run pilots and confirmation.</a:t>
+              <a:t>2. Authorize staged confirmation; one-seed pilots are not confirmation.</a:t>
             </a:r>
           </a:p>
           <a:p>
@@ -6673,7 +6566,7 @@
               </a:defRPr>
             </a:pPr>
             <a:r>
-              <a:t>3. Define equivalence margins; strengthen paired uncertainty analysis.</a:t>
+              <a:t>3. Approve statistical margins and a multiple-comparison plan.</a:t>
             </a:r>
           </a:p>
           <a:p>
@@ -6692,7 +6585,7 @@
               </a:defRPr>
             </a:pPr>
             <a:r>
-              <a:t>4. Review theory, finite-key assumptions, norm controls and novelty.</a:t>
+              <a:t>4. Independently review the corrected theorem and related work.</a:t>
             </a:r>
           </a:p>
           <a:p>

</xml_diff>

<commit_message>
Add SCface fourth dataset and scheme pilots; sync docs and figures
Sani supplied the authorized SCface archive directly on 2026-09-18.
Adds a mugshot-vs-surveillance BioHash key-pool study (130 identities,
2,851 embeddings, pools 1-3 pass the clustered-interval criterion) and
one-seed IoM-GRP/PolyProtect pilots (8 cells, 24 runs), frozen at
`69a93e4`. Extends the cross-dataset table (65->73 rows), all figures,
and the presentation to include SCface, and fixes a diagram text
overflow caused by the longer dataset label. Updates the status docs
(reports/README.md, final_research_status.md, figures/README.md,
ROADMAP.md, TODO.md, access_request_checklist.md) that previously said
SCface access was unavailable, and logs the work in research_log.md.

Co-Authored-By: Claude Sonnet 5 <noreply@anthropic.com>
</commit_message>
<xml_diff>
--- a/reports/slides/research_review.pptx
+++ b/reports/slides/research_review.pptx
@@ -524,7 +524,7 @@
           </a:p>
           <a:p>
             <a:r>
-              <a:t>New pilot code freeze: d5f4e89. Configuration: configs/attacks/scheme_extension_pilot.yaml. Sources: experiments/scheme_extension_pilot/{results_summary,paired_uncertainty,equivalence_sensitivity,native_utility}.csv. One-seed CPU pilots, 120-epoch cap; not a controlled ranking against earlier 400-epoch, three-seed studies. See figure_appendix.pdf for all figures, including native matching and uncertainty.</a:t>
+              <a:t>New pilot code freeze: d5f4e89. Configuration: configs/attacks/scheme_extension_pilot.yaml. Sources: experiments/scheme_extension_pilot/{results_summary,paired_uncertainty,equivalence_sensitivity,native_utility}.csv. SCface protocol and pilot freeze: 69a93e4; sources under experiments/scface_multiexposure and experiments/scface_scheme_extension_pilot. One-seed CPU pilots, 120-epoch cap; not a controlled ranking against earlier 400-epoch, three-seed studies. See figure_appendix.pdf for all figures, including native matching and uncertainty.</a:t>
             </a:r>
           </a:p>
         </p:txBody>
@@ -609,7 +609,7 @@
           </a:p>
           <a:p>
             <a:r>
-              <a:t>New pilot code freeze: d5f4e89. Configuration: configs/attacks/scheme_extension_pilot.yaml. Sources: experiments/scheme_extension_pilot/{results_summary,paired_uncertainty,equivalence_sensitivity,native_utility}.csv. One-seed CPU pilots, 120-epoch cap; not a controlled ranking against earlier 400-epoch, three-seed studies. See figure_appendix.pdf for all figures, including native matching and uncertainty.</a:t>
+              <a:t>New pilot code freeze: d5f4e89. Configuration: configs/attacks/scheme_extension_pilot.yaml. Sources: experiments/scheme_extension_pilot/{results_summary,paired_uncertainty,equivalence_sensitivity,native_utility}.csv. SCface protocol and pilot freeze: 69a93e4; sources under experiments/scface_multiexposure and experiments/scface_scheme_extension_pilot. One-seed CPU pilots, 120-epoch cap; not a controlled ranking against earlier 400-epoch, three-seed studies. See figure_appendix.pdf for all figures, including native matching and uncertainty.</a:t>
             </a:r>
           </a:p>
         </p:txBody>
@@ -694,7 +694,7 @@
           </a:p>
           <a:p>
             <a:r>
-              <a:t>New pilot code freeze: d5f4e89. Configuration: configs/attacks/scheme_extension_pilot.yaml. Sources: experiments/scheme_extension_pilot/{results_summary,paired_uncertainty,equivalence_sensitivity,native_utility}.csv. One-seed CPU pilots, 120-epoch cap; not a controlled ranking against earlier 400-epoch, three-seed studies. See figure_appendix.pdf for all figures, including native matching and uncertainty.</a:t>
+              <a:t>New pilot code freeze: d5f4e89. Configuration: configs/attacks/scheme_extension_pilot.yaml. Sources: experiments/scheme_extension_pilot/{results_summary,paired_uncertainty,equivalence_sensitivity,native_utility}.csv. SCface protocol and pilot freeze: 69a93e4; sources under experiments/scface_multiexposure and experiments/scface_scheme_extension_pilot. One-seed CPU pilots, 120-epoch cap; not a controlled ranking against earlier 400-epoch, three-seed studies. See figure_appendix.pdf for all figures, including native matching and uncertainty.</a:t>
             </a:r>
           </a:p>
         </p:txBody>
@@ -779,7 +779,7 @@
           </a:p>
           <a:p>
             <a:r>
-              <a:t>New pilot code freeze: d5f4e89. Configuration: configs/attacks/scheme_extension_pilot.yaml. Sources: experiments/scheme_extension_pilot/{results_summary,paired_uncertainty,equivalence_sensitivity,native_utility}.csv. One-seed CPU pilots, 120-epoch cap; not a controlled ranking against earlier 400-epoch, three-seed studies. See figure_appendix.pdf for all figures, including native matching and uncertainty.</a:t>
+              <a:t>New pilot code freeze: d5f4e89. Configuration: configs/attacks/scheme_extension_pilot.yaml. Sources: experiments/scheme_extension_pilot/{results_summary,paired_uncertainty,equivalence_sensitivity,native_utility}.csv. SCface protocol and pilot freeze: 69a93e4; sources under experiments/scface_multiexposure and experiments/scface_scheme_extension_pilot. One-seed CPU pilots, 120-epoch cap; not a controlled ranking against earlier 400-epoch, three-seed studies. See figure_appendix.pdf for all figures, including native matching and uncertainty.</a:t>
             </a:r>
           </a:p>
         </p:txBody>
@@ -864,7 +864,7 @@
           </a:p>
           <a:p>
             <a:r>
-              <a:t>New pilot code freeze: d5f4e89. Configuration: configs/attacks/scheme_extension_pilot.yaml. Sources: experiments/scheme_extension_pilot/{results_summary,paired_uncertainty,equivalence_sensitivity,native_utility}.csv. One-seed CPU pilots, 120-epoch cap; not a controlled ranking against earlier 400-epoch, three-seed studies. See figure_appendix.pdf for all figures, including native matching and uncertainty.</a:t>
+              <a:t>New pilot code freeze: d5f4e89. Configuration: configs/attacks/scheme_extension_pilot.yaml. Sources: experiments/scheme_extension_pilot/{results_summary,paired_uncertainty,equivalence_sensitivity,native_utility}.csv. SCface protocol and pilot freeze: 69a93e4; sources under experiments/scface_multiexposure and experiments/scface_scheme_extension_pilot. One-seed CPU pilots, 120-epoch cap; not a controlled ranking against earlier 400-epoch, three-seed studies. See figure_appendix.pdf for all figures, including native matching and uncertainty.</a:t>
             </a:r>
           </a:p>
         </p:txBody>
@@ -949,7 +949,7 @@
           </a:p>
           <a:p>
             <a:r>
-              <a:t>New pilot code freeze: d5f4e89. Configuration: configs/attacks/scheme_extension_pilot.yaml. Sources: experiments/scheme_extension_pilot/{results_summary,paired_uncertainty,equivalence_sensitivity,native_utility}.csv. One-seed CPU pilots, 120-epoch cap; not a controlled ranking against earlier 400-epoch, three-seed studies. See figure_appendix.pdf for all figures, including native matching and uncertainty.</a:t>
+              <a:t>New pilot code freeze: d5f4e89. Configuration: configs/attacks/scheme_extension_pilot.yaml. Sources: experiments/scheme_extension_pilot/{results_summary,paired_uncertainty,equivalence_sensitivity,native_utility}.csv. SCface protocol and pilot freeze: 69a93e4; sources under experiments/scface_multiexposure and experiments/scface_scheme_extension_pilot. One-seed CPU pilots, 120-epoch cap; not a controlled ranking against earlier 400-epoch, three-seed studies. See figure_appendix.pdf for all figures, including native matching and uncertainty.</a:t>
             </a:r>
           </a:p>
         </p:txBody>
@@ -1034,7 +1034,7 @@
           </a:p>
           <a:p>
             <a:r>
-              <a:t>New pilot code freeze: d5f4e89. Configuration: configs/attacks/scheme_extension_pilot.yaml. Sources: experiments/scheme_extension_pilot/{results_summary,paired_uncertainty,equivalence_sensitivity,native_utility}.csv. One-seed CPU pilots, 120-epoch cap; not a controlled ranking against earlier 400-epoch, three-seed studies. See figure_appendix.pdf for all figures, including native matching and uncertainty.</a:t>
+              <a:t>New pilot code freeze: d5f4e89. Configuration: configs/attacks/scheme_extension_pilot.yaml. Sources: experiments/scheme_extension_pilot/{results_summary,paired_uncertainty,equivalence_sensitivity,native_utility}.csv. SCface protocol and pilot freeze: 69a93e4; sources under experiments/scface_multiexposure and experiments/scface_scheme_extension_pilot. One-seed CPU pilots, 120-epoch cap; not a controlled ranking against earlier 400-epoch, three-seed studies. See figure_appendix.pdf for all figures, including native matching and uncertainty.</a:t>
             </a:r>
           </a:p>
         </p:txBody>
@@ -1119,7 +1119,7 @@
           </a:p>
           <a:p>
             <a:r>
-              <a:t>New pilot code freeze: d5f4e89. Configuration: configs/attacks/scheme_extension_pilot.yaml. Sources: experiments/scheme_extension_pilot/{results_summary,paired_uncertainty,equivalence_sensitivity,native_utility}.csv. One-seed CPU pilots, 120-epoch cap; not a controlled ranking against earlier 400-epoch, three-seed studies. See figure_appendix.pdf for all figures, including native matching and uncertainty.</a:t>
+              <a:t>New pilot code freeze: d5f4e89. Configuration: configs/attacks/scheme_extension_pilot.yaml. Sources: experiments/scheme_extension_pilot/{results_summary,paired_uncertainty,equivalence_sensitivity,native_utility}.csv. SCface protocol and pilot freeze: 69a93e4; sources under experiments/scface_multiexposure and experiments/scface_scheme_extension_pilot. One-seed CPU pilots, 120-epoch cap; not a controlled ranking against earlier 400-epoch, three-seed studies. See figure_appendix.pdf for all figures, including native matching and uncertainty.</a:t>
             </a:r>
           </a:p>
         </p:txBody>
@@ -4204,7 +4204,7 @@
               </a:defRPr>
             </a:pPr>
             <a:r>
-              <a:t>Research review draft | 12 September 2026 | 1/8</a:t>
+              <a:t>Research review draft | 18 September 2026 | 1/8</a:t>
             </a:r>
           </a:p>
         </p:txBody>
@@ -4502,7 +4502,7 @@
               </a:defRPr>
             </a:pPr>
             <a:r>
-              <a:t>Research review draft | 12 September 2026 | 2/8</a:t>
+              <a:t>Research review draft | 18 September 2026 | 2/8</a:t>
             </a:r>
           </a:p>
         </p:txBody>
@@ -4670,7 +4670,7 @@
               </a:defRPr>
             </a:pPr>
             <a:r>
-              <a:t>Research review draft | 12 September 2026 | 3/8</a:t>
+              <a:t>Research review draft | 18 September 2026 | 3/8</a:t>
             </a:r>
           </a:p>
         </p:txBody>
@@ -4893,7 +4893,7 @@
         </p:nvSpPr>
         <p:spPr>
           <a:xfrm>
-            <a:off x="548640" y="1901952"/>
+            <a:off x="548640" y="1828800"/>
             <a:ext cx="1645920" cy="457200"/>
           </a:xfrm>
           <a:prstGeom prst="rect">
@@ -4935,7 +4935,7 @@
         </p:nvSpPr>
         <p:spPr>
           <a:xfrm>
-            <a:off x="2377440" y="1901952"/>
+            <a:off x="2377440" y="1828800"/>
             <a:ext cx="1645920" cy="457200"/>
           </a:xfrm>
           <a:prstGeom prst="rect">
@@ -4977,7 +4977,7 @@
         </p:nvSpPr>
         <p:spPr>
           <a:xfrm>
-            <a:off x="4206240" y="1901952"/>
+            <a:off x="4206240" y="1828800"/>
             <a:ext cx="2103120" cy="457200"/>
           </a:xfrm>
           <a:prstGeom prst="rect">
@@ -5019,7 +5019,7 @@
         </p:nvSpPr>
         <p:spPr>
           <a:xfrm>
-            <a:off x="6492240" y="1901952"/>
+            <a:off x="6492240" y="1828800"/>
             <a:ext cx="2468880" cy="457200"/>
           </a:xfrm>
           <a:prstGeom prst="rect">
@@ -5061,7 +5061,7 @@
         </p:nvSpPr>
         <p:spPr>
           <a:xfrm>
-            <a:off x="9144000" y="1901952"/>
+            <a:off x="9144000" y="1828800"/>
             <a:ext cx="2468880" cy="457200"/>
           </a:xfrm>
           <a:prstGeom prst="rect">
@@ -5103,7 +5103,7 @@
         </p:nvSpPr>
         <p:spPr>
           <a:xfrm>
-            <a:off x="548640" y="2432304"/>
+            <a:off x="548640" y="2286000"/>
             <a:ext cx="1645920" cy="457200"/>
           </a:xfrm>
           <a:prstGeom prst="rect">
@@ -5145,7 +5145,7 @@
         </p:nvSpPr>
         <p:spPr>
           <a:xfrm>
-            <a:off x="2377440" y="2432304"/>
+            <a:off x="2377440" y="2286000"/>
             <a:ext cx="1645920" cy="457200"/>
           </a:xfrm>
           <a:prstGeom prst="rect">
@@ -5187,7 +5187,7 @@
         </p:nvSpPr>
         <p:spPr>
           <a:xfrm>
-            <a:off x="4206240" y="2432304"/>
+            <a:off x="4206240" y="2286000"/>
             <a:ext cx="2103120" cy="457200"/>
           </a:xfrm>
           <a:prstGeom prst="rect">
@@ -5229,7 +5229,7 @@
         </p:nvSpPr>
         <p:spPr>
           <a:xfrm>
-            <a:off x="6492240" y="2432304"/>
+            <a:off x="6492240" y="2286000"/>
             <a:ext cx="2468880" cy="457200"/>
           </a:xfrm>
           <a:prstGeom prst="rect">
@@ -5271,7 +5271,7 @@
         </p:nvSpPr>
         <p:spPr>
           <a:xfrm>
-            <a:off x="9144000" y="2432304"/>
+            <a:off x="9144000" y="2286000"/>
             <a:ext cx="2468880" cy="457200"/>
           </a:xfrm>
           <a:prstGeom prst="rect">
@@ -5313,7 +5313,7 @@
         </p:nvSpPr>
         <p:spPr>
           <a:xfrm>
-            <a:off x="548640" y="2962656"/>
+            <a:off x="548640" y="2743200"/>
             <a:ext cx="1645920" cy="457200"/>
           </a:xfrm>
           <a:prstGeom prst="rect">
@@ -5355,7 +5355,7 @@
         </p:nvSpPr>
         <p:spPr>
           <a:xfrm>
-            <a:off x="2377440" y="2962656"/>
+            <a:off x="2377440" y="2743200"/>
             <a:ext cx="1645920" cy="457200"/>
           </a:xfrm>
           <a:prstGeom prst="rect">
@@ -5397,7 +5397,7 @@
         </p:nvSpPr>
         <p:spPr>
           <a:xfrm>
-            <a:off x="4206240" y="2962656"/>
+            <a:off x="4206240" y="2743200"/>
             <a:ext cx="2103120" cy="457200"/>
           </a:xfrm>
           <a:prstGeom prst="rect">
@@ -5439,7 +5439,7 @@
         </p:nvSpPr>
         <p:spPr>
           <a:xfrm>
-            <a:off x="6492240" y="2962656"/>
+            <a:off x="6492240" y="2743200"/>
             <a:ext cx="2468880" cy="457200"/>
           </a:xfrm>
           <a:prstGeom prst="rect">
@@ -5481,7 +5481,7 @@
         </p:nvSpPr>
         <p:spPr>
           <a:xfrm>
-            <a:off x="9144000" y="2962656"/>
+            <a:off x="9144000" y="2743200"/>
             <a:ext cx="2468880" cy="457200"/>
           </a:xfrm>
           <a:prstGeom prst="rect">
@@ -5523,6 +5523,216 @@
         </p:nvSpPr>
         <p:spPr>
           <a:xfrm>
+            <a:off x="548640" y="3200400"/>
+            <a:ext cx="1645920" cy="457200"/>
+          </a:xfrm>
+          <a:prstGeom prst="rect">
+            <a:avLst/>
+          </a:prstGeom>
+          <a:noFill/>
+        </p:spPr>
+        <p:txBody>
+          <a:bodyPr wrap="none" lIns="0" rIns="0" tIns="0" bIns="0">
+            <a:spAutoFit/>
+          </a:bodyPr>
+          <a:lstStyle/>
+          <a:p>
+            <a:pPr>
+              <a:lnSpc>
+                <a:spcPct val="140000"/>
+              </a:lnSpc>
+              <a:spcAft>
+                <a:spcPts val="0"/>
+              </a:spcAft>
+              <a:defRPr sz="1500" b="0">
+                <a:solidFill>
+                  <a:srgbClr val="222222"/>
+                </a:solidFill>
+                <a:latin typeface="Times New Roman"/>
+              </a:defRPr>
+            </a:pPr>
+            <a:r>
+              <a:t>SCface</a:t>
+            </a:r>
+          </a:p>
+        </p:txBody>
+      </p:sp>
+      <p:sp>
+        <p:nvSpPr>
+          <p:cNvPr id="25" name="TextBox 24"/>
+          <p:cNvSpPr txBox="1"/>
+          <p:nvPr/>
+        </p:nvSpPr>
+        <p:spPr>
+          <a:xfrm>
+            <a:off x="2377440" y="3200400"/>
+            <a:ext cx="1645920" cy="457200"/>
+          </a:xfrm>
+          <a:prstGeom prst="rect">
+            <a:avLst/>
+          </a:prstGeom>
+          <a:noFill/>
+        </p:spPr>
+        <p:txBody>
+          <a:bodyPr wrap="none" lIns="0" rIns="0" tIns="0" bIns="0">
+            <a:spAutoFit/>
+          </a:bodyPr>
+          <a:lstStyle/>
+          <a:p>
+            <a:pPr>
+              <a:lnSpc>
+                <a:spcPct val="140000"/>
+              </a:lnSpc>
+              <a:spcAft>
+                <a:spcPts val="0"/>
+              </a:spcAft>
+              <a:defRPr sz="1500" b="0">
+                <a:solidFill>
+                  <a:srgbClr val="222222"/>
+                </a:solidFill>
+                <a:latin typeface="Times New Roman"/>
+              </a:defRPr>
+            </a:pPr>
+            <a:r>
+              <a:t>130</a:t>
+            </a:r>
+          </a:p>
+        </p:txBody>
+      </p:sp>
+      <p:sp>
+        <p:nvSpPr>
+          <p:cNvPr id="26" name="TextBox 25"/>
+          <p:cNvSpPr txBox="1"/>
+          <p:nvPr/>
+        </p:nvSpPr>
+        <p:spPr>
+          <a:xfrm>
+            <a:off x="4206240" y="3200400"/>
+            <a:ext cx="2103120" cy="457200"/>
+          </a:xfrm>
+          <a:prstGeom prst="rect">
+            <a:avLst/>
+          </a:prstGeom>
+          <a:noFill/>
+        </p:spPr>
+        <p:txBody>
+          <a:bodyPr wrap="none" lIns="0" rIns="0" tIns="0" bIns="0">
+            <a:spAutoFit/>
+          </a:bodyPr>
+          <a:lstStyle/>
+          <a:p>
+            <a:pPr>
+              <a:lnSpc>
+                <a:spcPct val="140000"/>
+              </a:lnSpc>
+              <a:spcAft>
+                <a:spcPts val="0"/>
+              </a:spcAft>
+              <a:defRPr sz="1500" b="0">
+                <a:solidFill>
+                  <a:srgbClr val="222222"/>
+                </a:solidFill>
+                <a:latin typeface="Times New Roman"/>
+              </a:defRPr>
+            </a:pPr>
+            <a:r>
+              <a:t>78/26/26</a:t>
+            </a:r>
+          </a:p>
+        </p:txBody>
+      </p:sp>
+      <p:sp>
+        <p:nvSpPr>
+          <p:cNvPr id="27" name="TextBox 26"/>
+          <p:cNvSpPr txBox="1"/>
+          <p:nvPr/>
+        </p:nvSpPr>
+        <p:spPr>
+          <a:xfrm>
+            <a:off x="6492240" y="3200400"/>
+            <a:ext cx="2468880" cy="457200"/>
+          </a:xfrm>
+          <a:prstGeom prst="rect">
+            <a:avLst/>
+          </a:prstGeom>
+          <a:noFill/>
+        </p:spPr>
+        <p:txBody>
+          <a:bodyPr wrap="none" lIns="0" rIns="0" tIns="0" bIns="0">
+            <a:spAutoFit/>
+          </a:bodyPr>
+          <a:lstStyle/>
+          <a:p>
+            <a:pPr>
+              <a:lnSpc>
+                <a:spcPct val="140000"/>
+              </a:lnSpc>
+              <a:spcAft>
+                <a:spcPts val="0"/>
+              </a:spcAft>
+              <a:defRPr sz="1500" b="0">
+                <a:solidFill>
+                  <a:srgbClr val="222222"/>
+                </a:solidFill>
+                <a:latin typeface="Times New Roman"/>
+              </a:defRPr>
+            </a:pPr>
+            <a:r>
+              <a:t>2,851 / 2,860</a:t>
+            </a:r>
+          </a:p>
+        </p:txBody>
+      </p:sp>
+      <p:sp>
+        <p:nvSpPr>
+          <p:cNvPr id="28" name="TextBox 27"/>
+          <p:cNvSpPr txBox="1"/>
+          <p:nvPr/>
+        </p:nvSpPr>
+        <p:spPr>
+          <a:xfrm>
+            <a:off x="9144000" y="3200400"/>
+            <a:ext cx="2468880" cy="457200"/>
+          </a:xfrm>
+          <a:prstGeom prst="rect">
+            <a:avLst/>
+          </a:prstGeom>
+          <a:noFill/>
+        </p:spPr>
+        <p:txBody>
+          <a:bodyPr wrap="none" lIns="0" rIns="0" tIns="0" bIns="0">
+            <a:spAutoFit/>
+          </a:bodyPr>
+          <a:lstStyle/>
+          <a:p>
+            <a:pPr>
+              <a:lnSpc>
+                <a:spcPct val="140000"/>
+              </a:lnSpc>
+              <a:spcAft>
+                <a:spcPts val="0"/>
+              </a:spcAft>
+              <a:defRPr sz="1500" b="0">
+                <a:solidFill>
+                  <a:srgbClr val="222222"/>
+                </a:solidFill>
+                <a:latin typeface="Times New Roman"/>
+              </a:defRPr>
+            </a:pPr>
+            <a:r>
+              <a:t>Camera/distance</a:t>
+            </a:r>
+          </a:p>
+        </p:txBody>
+      </p:sp>
+      <p:sp>
+        <p:nvSpPr>
+          <p:cNvPr id="29" name="TextBox 28"/>
+          <p:cNvSpPr txBox="1"/>
+          <p:nvPr/>
+        </p:nvSpPr>
+        <p:spPr>
+          <a:xfrm>
             <a:off x="548640" y="3794760"/>
             <a:ext cx="11064240" cy="1691640"/>
           </a:xfrm>
@@ -5552,7 +5762,7 @@
               </a:defRPr>
             </a:pPr>
             <a:r>
-              <a:t>BioHash: 128 bits; three datasets; includes a Haar-sign control on MOBIO.</a:t>
+              <a:t>BioHash: 128 bits; four datasets; includes a Haar-sign control on MOBIO.</a:t>
             </a:r>
           </a:p>
           <a:p>
@@ -5590,7 +5800,7 @@
               </a:defRPr>
             </a:pPr>
             <a:r>
-              <a:t>IoM-GRP: 300 categorical codes (q=16); MOBIO/FEI pilots.</a:t>
+              <a:t>IoM-GRP: 300 categorical codes (q=16); MOBIO/FEI/SCface pilots.</a:t>
             </a:r>
           </a:p>
           <a:p>
@@ -5609,14 +5819,14 @@
               </a:defRPr>
             </a:pPr>
             <a:r>
-              <a:t>PolyProtect: 170 real values (m=5, overlap=2); MOBIO/FEI pilots.</a:t>
-            </a:r>
-          </a:p>
-        </p:txBody>
-      </p:sp>
-      <p:sp>
-        <p:nvSpPr>
-          <p:cNvPr id="25" name="TextBox 24"/>
+              <a:t>PolyProtect: 170 real values (m=5, overlap=2); MOBIO/FEI/SCface pilots.</a:t>
+            </a:r>
+          </a:p>
+        </p:txBody>
+      </p:sp>
+      <p:sp>
+        <p:nvSpPr>
+          <p:cNvPr id="30" name="TextBox 29"/>
           <p:cNvSpPr txBox="1"/>
           <p:nvPr/>
         </p:nvSpPr>
@@ -5651,7 +5861,7 @@
               </a:defRPr>
             </a:pPr>
             <a:r>
-              <a:t>FEI: 22 low-illumination failures; all identities retain a gallery image plus 10 exposures.</a:t>
+              <a:t>SCface: mugshot gallery and visible surveillance probes; 9 detection failures, all identities eligible.</a:t>
             </a:r>
           </a:p>
         </p:txBody>
@@ -5753,7 +5963,7 @@
               </a:defRPr>
             </a:pPr>
             <a:r>
-              <a:t>Research review draft | 12 September 2026 | 4/8</a:t>
+              <a:t>Research review draft | 18 September 2026 | 4/8</a:t>
             </a:r>
           </a:p>
         </p:txBody>
@@ -5921,7 +6131,7 @@
               </a:defRPr>
             </a:pPr>
             <a:r>
-              <a:t>Research review draft | 12 September 2026 | 5/8</a:t>
+              <a:t>Research review draft | 18 September 2026 | 5/8</a:t>
             </a:r>
           </a:p>
         </p:txBody>
@@ -5987,7 +6197,7 @@
               </a:defRPr>
             </a:pPr>
             <a:r>
-              <a:t>65 conditions from 11 earlier studies. New one-seed pilots are reported separately.</a:t>
+              <a:t>73 conditions from 12 earlier studies. New one-seed pilots are reported separately.</a:t>
             </a:r>
           </a:p>
         </p:txBody>
@@ -6089,7 +6299,7 @@
               </a:defRPr>
             </a:pPr>
             <a:r>
-              <a:t>Research review draft | 12 September 2026 | 6/8</a:t>
+              <a:t>Research review draft | 18 September 2026 | 6/8</a:t>
             </a:r>
           </a:p>
         </p:txBody>
@@ -6257,7 +6467,7 @@
               </a:defRPr>
             </a:pPr>
             <a:r>
-              <a:t>Research review draft | 12 September 2026 | 7/8</a:t>
+              <a:t>Research review draft | 18 September 2026 | 7/8</a:t>
             </a:r>
           </a:p>
         </p:txBody>
@@ -6278,8 +6488,8 @@
         </p:blipFill>
         <p:spPr>
           <a:xfrm>
-            <a:off x="2935877" y="960120"/>
-            <a:ext cx="6289765" cy="4892040"/>
+            <a:off x="1625509" y="960120"/>
+            <a:ext cx="8910501" cy="4892040"/>
           </a:xfrm>
           <a:prstGeom prst="rect">
             <a:avLst/>
@@ -6323,7 +6533,7 @@
               </a:defRPr>
             </a:pPr>
             <a:r>
-              <a:t>Fresh PolyProtect native matching: MOBIO 12.73%, FEI 13.73%; separate task, not a privacy result.</a:t>
+              <a:t>Fresh PolyProtect native top-1: MOBIO 12.73%, FEI 13.73%, SCface 10.66%; separate diagnostic.</a:t>
             </a:r>
           </a:p>
         </p:txBody>
@@ -6425,7 +6635,7 @@
               </a:defRPr>
             </a:pPr>
             <a:r>
-              <a:t>Research review draft | 12 September 2026 | 8/8</a:t>
+              <a:t>Research review draft | 18 September 2026 | 8/8</a:t>
             </a:r>
           </a:p>
         </p:txBody>
@@ -6467,7 +6677,7 @@
               </a:defRPr>
             </a:pPr>
             <a:r>
-              <a:t>Completed: two new schemes, 16 pilot cells, paired intervals, per-seed results.</a:t>
+              <a:t>Completed: two added datasets, two new schemes, 24 pilot cells, paired intervals.</a:t>
             </a:r>
           </a:p>
         </p:txBody>
@@ -6528,7 +6738,7 @@
               </a:defRPr>
             </a:pPr>
             <a:r>
-              <a:t>1. Obtain authorized access to the next dataset.</a:t>
+              <a:t>1. Freeze and authorize staged confirmation; one-seed pilots are not confirmation.</a:t>
             </a:r>
           </a:p>
           <a:p>
@@ -6547,7 +6757,7 @@
               </a:defRPr>
             </a:pPr>
             <a:r>
-              <a:t>2. Authorize staged confirmation; one-seed pilots are not confirmation.</a:t>
+              <a:t>2. Decide whether AgeDB adds enough value for a third added dataset.</a:t>
             </a:r>
           </a:p>
           <a:p>

</xml_diff>

<commit_message>
Compared literature and rerun experiments within local cpu
</commit_message>
<xml_diff>
--- a/reports/slides/research_review.pptx
+++ b/reports/slides/research_review.pptx
@@ -13,6 +13,8 @@
     <p:sldId id="261" r:id="rId13"/>
     <p:sldId id="262" r:id="rId14"/>
     <p:sldId id="263" r:id="rId15"/>
+    <p:sldId id="264" r:id="rId16"/>
+    <p:sldId id="265" r:id="rId17"/>
   </p:sldIdLst>
   <p:sldSz cx="12191999" cy="6858000" type="screen4x3"/>
   <p:notesSz cx="6858000" cy="9144000"/>
@@ -549,6 +551,91 @@
 </p:notes>
 </file>
 
+<file path=ppt/notesSlides/notesSlide10.xml><?xml version="1.0" encoding="utf-8"?>
+<p:notes xmlns:a="http://schemas.openxmlformats.org/drawingml/2006/main" xmlns:p="http://schemas.openxmlformats.org/presentationml/2006/main" xmlns:r="http://schemas.openxmlformats.org/officeDocument/2006/relationships">
+  <p:cSld>
+    <p:spTree>
+      <p:nvGrpSpPr>
+        <p:cNvPr id="1" name=""/>
+        <p:cNvGrpSpPr/>
+        <p:nvPr/>
+      </p:nvGrpSpPr>
+      <p:grpSpPr>
+        <a:xfrm>
+          <a:off x="0" y="0"/>
+          <a:ext cx="0" cy="0"/>
+          <a:chOff x="0" y="0"/>
+          <a:chExt cx="0" cy="0"/>
+        </a:xfrm>
+      </p:grpSpPr>
+      <p:sp>
+        <p:nvSpPr>
+          <p:cNvPr id="2" name="Slide Image Placeholder 1"/>
+          <p:cNvSpPr>
+            <a:spLocks noGrp="1"/>
+          </p:cNvSpPr>
+          <p:nvPr>
+            <p:ph type="sldImg" idx="2"/>
+          </p:nvPr>
+        </p:nvSpPr>
+        <p:spPr/>
+      </p:sp>
+      <p:sp>
+        <p:nvSpPr>
+          <p:cNvPr id="3" name="Notes Placeholder 2"/>
+          <p:cNvSpPr>
+            <a:spLocks noGrp="1"/>
+          </p:cNvSpPr>
+          <p:nvPr>
+            <p:ph type="body" idx="3" sz="quarter"/>
+          </p:nvPr>
+        </p:nvSpPr>
+        <p:spPr/>
+        <p:txBody>
+          <a:bodyPr/>
+          <a:lstStyle/>
+          <a:p>
+            <a:r>
+              <a:t>Evidence baseline: commit 655ae1ecc2c9fc0aa80c828fe0303753296f66df. FEI run recorded base commit d1e4ceb3f975fb47d9a8321c47484bb1411f5239 with FEI additions uncommitted.</a:t>
+            </a:r>
+          </a:p>
+          <a:p>
+            <a:r>
+              <a:t>Sources: experiments/cross_dataset_key_pool_summary.csv; experiments/fei_multiexposure/README.md; experiments/mobio_mechanism_controls/results_summary.csv; experiments/mobio_correlation_controls/results_summary.csv.</a:t>
+            </a:r>
+          </a:p>
+          <a:p>
+            <a:r>
+              <a:t>Configuration: configs/attacks/fei_key_pool_boundary.yaml. See reports/figures/README.md for figure captions and docs/ROADMAP.md for pending gates. Diagram symbols are schematic, not biometric examples.</a:t>
+            </a:r>
+          </a:p>
+          <a:p>
+            <a:r>
+              <a:t>New pilot code freeze: d5f4e89. Configuration: configs/attacks/scheme_extension_pilot.yaml. Sources: experiments/scheme_extension_pilot/{results_summary,paired_uncertainty,equivalence_sensitivity,native_utility}.csv. SCface protocol and pilot freeze: 69a93e4; sources under experiments/scface_multiexposure and experiments/scface_scheme_extension_pilot. One-seed CPU pilots, 120-epoch cap; not a controlled ranking against earlier 400-epoch, three-seed studies. See figure_appendix.pdf for all figures, including native matching and uncertainty. Follow-up: experiments/scheme_followup_2026-09-18; 216 endpoints, two identity partitions, three model seeds. Pre-execution source/config hashes: execution_manifest.json; base commit 4352eeb, dirty working tree recorded. Primary sign-flip tests: Holm family 8; native gallery-label permutations: Holm family 12.</a:t>
+            </a:r>
+          </a:p>
+        </p:txBody>
+      </p:sp>
+      <p:sp>
+        <p:nvSpPr>
+          <p:cNvPr id="4" name="Slide Number Placeholder 3"/>
+          <p:cNvSpPr>
+            <a:spLocks noGrp="1"/>
+          </p:cNvSpPr>
+          <p:nvPr>
+            <p:ph type="sldNum" idx="5" sz="quarter"/>
+          </p:nvPr>
+        </p:nvSpPr>
+        <p:spPr/>
+      </p:sp>
+    </p:spTree>
+  </p:cSld>
+  <p:clrMapOvr>
+    <a:masterClrMapping/>
+  </p:clrMapOvr>
+</p:notes>
+</file>
+
 <file path=ppt/notesSlides/notesSlide2.xml><?xml version="1.0" encoding="utf-8"?>
 <p:notes xmlns:a="http://schemas.openxmlformats.org/drawingml/2006/main" xmlns:p="http://schemas.openxmlformats.org/presentationml/2006/main" xmlns:r="http://schemas.openxmlformats.org/officeDocument/2006/relationships">
   <p:cSld>
@@ -1060,6 +1147,91 @@
 </file>
 
 <file path=ppt/notesSlides/notesSlide8.xml><?xml version="1.0" encoding="utf-8"?>
+<p:notes xmlns:a="http://schemas.openxmlformats.org/drawingml/2006/main" xmlns:p="http://schemas.openxmlformats.org/presentationml/2006/main" xmlns:r="http://schemas.openxmlformats.org/officeDocument/2006/relationships">
+  <p:cSld>
+    <p:spTree>
+      <p:nvGrpSpPr>
+        <p:cNvPr id="1" name=""/>
+        <p:cNvGrpSpPr/>
+        <p:nvPr/>
+      </p:nvGrpSpPr>
+      <p:grpSpPr>
+        <a:xfrm>
+          <a:off x="0" y="0"/>
+          <a:ext cx="0" cy="0"/>
+          <a:chOff x="0" y="0"/>
+          <a:chExt cx="0" cy="0"/>
+        </a:xfrm>
+      </p:grpSpPr>
+      <p:sp>
+        <p:nvSpPr>
+          <p:cNvPr id="2" name="Slide Image Placeholder 1"/>
+          <p:cNvSpPr>
+            <a:spLocks noGrp="1"/>
+          </p:cNvSpPr>
+          <p:nvPr>
+            <p:ph type="sldImg" idx="2"/>
+          </p:nvPr>
+        </p:nvSpPr>
+        <p:spPr/>
+      </p:sp>
+      <p:sp>
+        <p:nvSpPr>
+          <p:cNvPr id="3" name="Notes Placeholder 2"/>
+          <p:cNvSpPr>
+            <a:spLocks noGrp="1"/>
+          </p:cNvSpPr>
+          <p:nvPr>
+            <p:ph type="body" idx="3" sz="quarter"/>
+          </p:nvPr>
+        </p:nvSpPr>
+        <p:spPr/>
+        <p:txBody>
+          <a:bodyPr/>
+          <a:lstStyle/>
+          <a:p>
+            <a:r>
+              <a:t>Evidence baseline: commit 655ae1ecc2c9fc0aa80c828fe0303753296f66df. FEI run recorded base commit d1e4ceb3f975fb47d9a8321c47484bb1411f5239 with FEI additions uncommitted.</a:t>
+            </a:r>
+          </a:p>
+          <a:p>
+            <a:r>
+              <a:t>Sources: experiments/cross_dataset_key_pool_summary.csv; experiments/fei_multiexposure/README.md; experiments/mobio_mechanism_controls/results_summary.csv; experiments/mobio_correlation_controls/results_summary.csv.</a:t>
+            </a:r>
+          </a:p>
+          <a:p>
+            <a:r>
+              <a:t>Configuration: configs/attacks/fei_key_pool_boundary.yaml. See reports/figures/README.md for figure captions and docs/ROADMAP.md for pending gates. Diagram symbols are schematic, not biometric examples.</a:t>
+            </a:r>
+          </a:p>
+          <a:p>
+            <a:r>
+              <a:t>New pilot code freeze: d5f4e89. Configuration: configs/attacks/scheme_extension_pilot.yaml. Sources: experiments/scheme_extension_pilot/{results_summary,paired_uncertainty,equivalence_sensitivity,native_utility}.csv. SCface protocol and pilot freeze: 69a93e4; sources under experiments/scface_multiexposure and experiments/scface_scheme_extension_pilot. One-seed CPU pilots, 120-epoch cap; not a controlled ranking against earlier 400-epoch, three-seed studies. See figure_appendix.pdf for all figures, including native matching and uncertainty. Follow-up: experiments/scheme_followup_2026-09-18; 216 endpoints, two identity partitions, three model seeds. Pre-execution source/config hashes: execution_manifest.json; base commit 4352eeb, dirty working tree recorded. Primary sign-flip tests: Holm family 8; native gallery-label permutations: Holm family 12.</a:t>
+            </a:r>
+          </a:p>
+        </p:txBody>
+      </p:sp>
+      <p:sp>
+        <p:nvSpPr>
+          <p:cNvPr id="4" name="Slide Number Placeholder 3"/>
+          <p:cNvSpPr>
+            <a:spLocks noGrp="1"/>
+          </p:cNvSpPr>
+          <p:nvPr>
+            <p:ph type="sldNum" idx="5" sz="quarter"/>
+          </p:nvPr>
+        </p:nvSpPr>
+        <p:spPr/>
+      </p:sp>
+    </p:spTree>
+  </p:cSld>
+  <p:clrMapOvr>
+    <a:masterClrMapping/>
+  </p:clrMapOvr>
+</p:notes>
+</file>
+
+<file path=ppt/notesSlides/notesSlide9.xml><?xml version="1.0" encoding="utf-8"?>
 <p:notes xmlns:a="http://schemas.openxmlformats.org/drawingml/2006/main" xmlns:p="http://schemas.openxmlformats.org/presentationml/2006/main" xmlns:r="http://schemas.openxmlformats.org/officeDocument/2006/relationships">
   <p:cSld>
     <p:spTree>
@@ -4204,7 +4376,7 @@
               </a:defRPr>
             </a:pPr>
             <a:r>
-              <a:t>Research review draft | 18 September 2026 | 1/8</a:t>
+              <a:t>Research review draft | 18 September 2026 | 1/10</a:t>
             </a:r>
           </a:p>
         </p:txBody>
@@ -4401,6 +4573,174 @@
             </a:pPr>
             <a:r>
               <a:t>Four datasets; hidden-key protocols; matched MOBIO/FEI follow-up with 216 trained endpoints.</a:t>
+            </a:r>
+          </a:p>
+        </p:txBody>
+      </p:sp>
+    </p:spTree>
+  </p:cSld>
+  <p:clrMapOvr>
+    <a:masterClrMapping/>
+  </p:clrMapOvr>
+</p:sld>
+</file>
+
+<file path=ppt/slides/slide10.xml><?xml version="1.0" encoding="utf-8"?>
+<p:sld xmlns:a="http://schemas.openxmlformats.org/drawingml/2006/main" xmlns:p="http://schemas.openxmlformats.org/presentationml/2006/main" xmlns:r="http://schemas.openxmlformats.org/officeDocument/2006/relationships">
+  <p:cSld>
+    <p:spTree>
+      <p:nvGrpSpPr>
+        <p:cNvPr id="1" name=""/>
+        <p:cNvGrpSpPr/>
+        <p:nvPr/>
+      </p:nvGrpSpPr>
+      <p:grpSpPr/>
+      <p:sp>
+        <p:nvSpPr>
+          <p:cNvPr id="2" name="TextBox 1"/>
+          <p:cNvSpPr txBox="1"/>
+          <p:nvPr/>
+        </p:nvSpPr>
+        <p:spPr>
+          <a:xfrm>
+            <a:off x="548640" y="274320"/>
+            <a:ext cx="11064240" cy="548640"/>
+          </a:xfrm>
+          <a:prstGeom prst="rect">
+            <a:avLst/>
+          </a:prstGeom>
+          <a:noFill/>
+        </p:spPr>
+        <p:txBody>
+          <a:bodyPr wrap="none" lIns="0" rIns="0" tIns="0" bIns="0">
+            <a:spAutoFit/>
+          </a:bodyPr>
+          <a:lstStyle/>
+          <a:p>
+            <a:pPr>
+              <a:lnSpc>
+                <a:spcPct val="140000"/>
+              </a:lnSpc>
+              <a:spcAft>
+                <a:spcPts val="0"/>
+              </a:spcAft>
+              <a:defRPr sz="2500" b="1">
+                <a:solidFill>
+                  <a:srgbClr val="222222"/>
+                </a:solidFill>
+                <a:latin typeface="Times New Roman"/>
+              </a:defRPr>
+            </a:pPr>
+            <a:r>
+              <a:t>Failure analysis: aggregation is not always better</a:t>
+            </a:r>
+          </a:p>
+        </p:txBody>
+      </p:sp>
+      <p:sp>
+        <p:nvSpPr>
+          <p:cNvPr id="3" name="TextBox 2"/>
+          <p:cNvSpPr txBox="1"/>
+          <p:nvPr/>
+        </p:nvSpPr>
+        <p:spPr>
+          <a:xfrm>
+            <a:off x="548640" y="6464808"/>
+            <a:ext cx="11064240" cy="274320"/>
+          </a:xfrm>
+          <a:prstGeom prst="rect">
+            <a:avLst/>
+          </a:prstGeom>
+          <a:noFill/>
+        </p:spPr>
+        <p:txBody>
+          <a:bodyPr wrap="none" lIns="0" rIns="0" tIns="0" bIns="0">
+            <a:spAutoFit/>
+          </a:bodyPr>
+          <a:lstStyle/>
+          <a:p>
+            <a:pPr>
+              <a:lnSpc>
+                <a:spcPct val="140000"/>
+              </a:lnSpc>
+              <a:spcAft>
+                <a:spcPts val="0"/>
+              </a:spcAft>
+              <a:defRPr sz="1100" b="0">
+                <a:solidFill>
+                  <a:srgbClr val="666666"/>
+                </a:solidFill>
+                <a:latin typeface="Times New Roman"/>
+              </a:defRPr>
+            </a:pPr>
+            <a:r>
+              <a:t>Research review draft | 18 September 2026 | 10/10</a:t>
+            </a:r>
+          </a:p>
+        </p:txBody>
+      </p:sp>
+      <p:pic>
+        <p:nvPicPr>
+          <p:cNvPr id="4" name="Picture 3" descr="fig_followup_failures.png"/>
+          <p:cNvPicPr>
+            <a:picLocks noChangeAspect="1"/>
+          </p:cNvPicPr>
+          <p:nvPr/>
+        </p:nvPicPr>
+        <p:blipFill>
+          <a:blip r:embed="rId2"/>
+          <a:stretch>
+            <a:fillRect/>
+          </a:stretch>
+        </p:blipFill>
+        <p:spPr>
+          <a:xfrm>
+            <a:off x="1044836" y="960120"/>
+            <a:ext cx="10071847" cy="4892040"/>
+          </a:xfrm>
+          <a:prstGeom prst="rect">
+            <a:avLst/>
+          </a:prstGeom>
+        </p:spPr>
+      </p:pic>
+      <p:sp>
+        <p:nvSpPr>
+          <p:cNvPr id="5" name="TextBox 4"/>
+          <p:cNvSpPr txBox="1"/>
+          <p:nvPr/>
+        </p:nvSpPr>
+        <p:spPr>
+          <a:xfrm>
+            <a:off x="548640" y="6016752"/>
+            <a:ext cx="11064240" cy="365760"/>
+          </a:xfrm>
+          <a:prstGeom prst="rect">
+            <a:avLst/>
+          </a:prstGeom>
+          <a:noFill/>
+        </p:spPr>
+        <p:txBody>
+          <a:bodyPr wrap="none" lIns="0" rIns="0" tIns="0" bIns="0">
+            <a:spAutoFit/>
+          </a:bodyPr>
+          <a:lstStyle/>
+          <a:p>
+            <a:pPr>
+              <a:lnSpc>
+                <a:spcPct val="140000"/>
+              </a:lnSpc>
+              <a:spcAft>
+                <a:spcPts val="0"/>
+              </a:spcAft>
+              <a:defRPr sz="1200" b="0">
+                <a:solidFill>
+                  <a:srgbClr val="222222"/>
+                </a:solidFill>
+                <a:latin typeface="Times New Roman"/>
+              </a:defRPr>
+            </a:pPr>
+            <a:r>
+              <a:t>Original primary family unchanged. All 48 contrasts, including significant losses, are reported separately from historical exploration.</a:t>
             </a:r>
           </a:p>
         </p:txBody>
@@ -4502,7 +4842,7 @@
               </a:defRPr>
             </a:pPr>
             <a:r>
-              <a:t>Research review draft | 18 September 2026 | 2/8</a:t>
+              <a:t>Research review draft | 18 September 2026 | 2/10</a:t>
             </a:r>
           </a:p>
         </p:txBody>
@@ -4670,7 +5010,7 @@
               </a:defRPr>
             </a:pPr>
             <a:r>
-              <a:t>Research review draft | 18 September 2026 | 3/8</a:t>
+              <a:t>Research review draft | 18 September 2026 | 3/10</a:t>
             </a:r>
           </a:p>
         </p:txBody>
@@ -5963,7 +6303,7 @@
               </a:defRPr>
             </a:pPr>
             <a:r>
-              <a:t>Research review draft | 18 September 2026 | 4/8</a:t>
+              <a:t>Research review draft | 18 September 2026 | 4/10</a:t>
             </a:r>
           </a:p>
         </p:txBody>
@@ -6131,7 +6471,7 @@
               </a:defRPr>
             </a:pPr>
             <a:r>
-              <a:t>Research review draft | 18 September 2026 | 5/8</a:t>
+              <a:t>Research review draft | 18 September 2026 | 5/10</a:t>
             </a:r>
           </a:p>
         </p:txBody>
@@ -6299,7 +6639,7 @@
               </a:defRPr>
             </a:pPr>
             <a:r>
-              <a:t>Research review draft | 18 September 2026 | 6/8</a:t>
+              <a:t>Research review draft | 18 September 2026 | 6/10</a:t>
             </a:r>
           </a:p>
         </p:txBody>
@@ -6467,7 +6807,7 @@
               </a:defRPr>
             </a:pPr>
             <a:r>
-              <a:t>Research review draft | 18 September 2026 | 7/8</a:t>
+              <a:t>Research review draft | 18 September 2026 | 7/10</a:t>
             </a:r>
           </a:p>
         </p:txBody>
@@ -6635,7 +6975,7 @@
               </a:defRPr>
             </a:pPr>
             <a:r>
-              <a:t>Research review draft | 18 September 2026 | 8/8</a:t>
+              <a:t>Research review draft | 18 September 2026 | 8/10</a:t>
             </a:r>
           </a:p>
         </p:txBody>
@@ -6702,6 +7042,174 @@
             </a:pPr>
             <a:r>
               <a:t>Protected-gallery matching is distinct from learned linkage. Radial sensitivity does not establish natural norm leakage.</a:t>
+            </a:r>
+          </a:p>
+        </p:txBody>
+      </p:sp>
+    </p:spTree>
+  </p:cSld>
+  <p:clrMapOvr>
+    <a:masterClrMapping/>
+  </p:clrMapOvr>
+</p:sld>
+</file>
+
+<file path=ppt/slides/slide9.xml><?xml version="1.0" encoding="utf-8"?>
+<p:sld xmlns:a="http://schemas.openxmlformats.org/drawingml/2006/main" xmlns:p="http://schemas.openxmlformats.org/presentationml/2006/main" xmlns:r="http://schemas.openxmlformats.org/officeDocument/2006/relationships">
+  <p:cSld>
+    <p:spTree>
+      <p:nvGrpSpPr>
+        <p:cNvPr id="1" name=""/>
+        <p:cNvGrpSpPr/>
+        <p:nvPr/>
+      </p:nvGrpSpPr>
+      <p:grpSpPr/>
+      <p:sp>
+        <p:nvSpPr>
+          <p:cNvPr id="2" name="TextBox 1"/>
+          <p:cNvSpPr txBox="1"/>
+          <p:nvPr/>
+        </p:nvSpPr>
+        <p:spPr>
+          <a:xfrm>
+            <a:off x="548640" y="274320"/>
+            <a:ext cx="11064240" cy="548640"/>
+          </a:xfrm>
+          <a:prstGeom prst="rect">
+            <a:avLst/>
+          </a:prstGeom>
+          <a:noFill/>
+        </p:spPr>
+        <p:txBody>
+          <a:bodyPr wrap="none" lIns="0" rIns="0" tIns="0" bIns="0">
+            <a:spAutoFit/>
+          </a:bodyPr>
+          <a:lstStyle/>
+          <a:p>
+            <a:pPr>
+              <a:lnSpc>
+                <a:spcPct val="140000"/>
+              </a:lnSpc>
+              <a:spcAft>
+                <a:spcPts val="0"/>
+              </a:spcAft>
+              <a:defRPr sz="2500" b="1">
+                <a:solidFill>
+                  <a:srgbClr val="222222"/>
+                </a:solidFill>
+                <a:latin typeface="Times New Roman"/>
+              </a:defRPr>
+            </a:pPr>
+            <a:r>
+              <a:t>Genuine raw-input controls</a:t>
+            </a:r>
+          </a:p>
+        </p:txBody>
+      </p:sp>
+      <p:sp>
+        <p:nvSpPr>
+          <p:cNvPr id="3" name="TextBox 2"/>
+          <p:cNvSpPr txBox="1"/>
+          <p:nvPr/>
+        </p:nvSpPr>
+        <p:spPr>
+          <a:xfrm>
+            <a:off x="548640" y="6464808"/>
+            <a:ext cx="11064240" cy="274320"/>
+          </a:xfrm>
+          <a:prstGeom prst="rect">
+            <a:avLst/>
+          </a:prstGeom>
+          <a:noFill/>
+        </p:spPr>
+        <p:txBody>
+          <a:bodyPr wrap="none" lIns="0" rIns="0" tIns="0" bIns="0">
+            <a:spAutoFit/>
+          </a:bodyPr>
+          <a:lstStyle/>
+          <a:p>
+            <a:pPr>
+              <a:lnSpc>
+                <a:spcPct val="140000"/>
+              </a:lnSpc>
+              <a:spcAft>
+                <a:spcPts val="0"/>
+              </a:spcAft>
+              <a:defRPr sz="1100" b="0">
+                <a:solidFill>
+                  <a:srgbClr val="666666"/>
+                </a:solidFill>
+                <a:latin typeface="Times New Roman"/>
+              </a:defRPr>
+            </a:pPr>
+            <a:r>
+              <a:t>Research review draft | 18 September 2026 | 9/10</a:t>
+            </a:r>
+          </a:p>
+        </p:txBody>
+      </p:sp>
+      <p:pic>
+        <p:nvPicPr>
+          <p:cNvPr id="4" name="Picture 3" descr="fig_native_norm_audit.png"/>
+          <p:cNvPicPr>
+            <a:picLocks noChangeAspect="1"/>
+          </p:cNvPicPr>
+          <p:nvPr/>
+        </p:nvPicPr>
+        <p:blipFill>
+          <a:blip r:embed="rId2"/>
+          <a:stretch>
+            <a:fillRect/>
+          </a:stretch>
+        </p:blipFill>
+        <p:spPr>
+          <a:xfrm>
+            <a:off x="548640" y="982544"/>
+            <a:ext cx="11064240" cy="4847190"/>
+          </a:xfrm>
+          <a:prstGeom prst="rect">
+            <a:avLst/>
+          </a:prstGeom>
+        </p:spPr>
+      </p:pic>
+      <p:sp>
+        <p:nvSpPr>
+          <p:cNvPr id="5" name="TextBox 4"/>
+          <p:cNvSpPr txBox="1"/>
+          <p:nvPr/>
+        </p:nvSpPr>
+        <p:spPr>
+          <a:xfrm>
+            <a:off x="548640" y="6016752"/>
+            <a:ext cx="11064240" cy="365760"/>
+          </a:xfrm>
+          <a:prstGeom prst="rect">
+            <a:avLst/>
+          </a:prstGeom>
+          <a:noFill/>
+        </p:spPr>
+        <p:txBody>
+          <a:bodyPr wrap="none" lIns="0" rIns="0" tIns="0" bIns="0">
+            <a:spAutoFit/>
+          </a:bodyPr>
+          <a:lstStyle/>
+          <a:p>
+            <a:pPr>
+              <a:lnSpc>
+                <a:spcPct val="140000"/>
+              </a:lnSpc>
+              <a:spcAft>
+                <a:spcPts val="0"/>
+              </a:spcAft>
+              <a:defRPr sz="1200" b="0">
+                <a:solidFill>
+                  <a:srgbClr val="222222"/>
+                </a:solidFill>
+                <a:latin typeface="Times New Roman"/>
+              </a:defRPr>
+            </a:pPr>
+            <a:r>
+              <a:t>4,177 raw extractions verified. Separate scalar and SciPy checks reproduce native matching; stronger parameter policies remain untested.</a:t>
             </a:r>
           </a:p>
         </p:txBody>

</xml_diff>

<commit_message>
Add independent pool replication, prediction baseline and research update
</commit_message>
<xml_diff>
--- a/reports/slides/research_review.pptx
+++ b/reports/slides/research_review.pptx
@@ -15,6 +15,8 @@
     <p:sldId id="263" r:id="rId15"/>
     <p:sldId id="264" r:id="rId16"/>
     <p:sldId id="265" r:id="rId17"/>
+    <p:sldId id="266" r:id="rId18"/>
+    <p:sldId id="267" r:id="rId19"/>
   </p:sldIdLst>
   <p:sldSz cx="12191999" cy="6858000" type="screen4x3"/>
   <p:notesSz cx="6858000" cy="9144000"/>
@@ -526,7 +528,7 @@
           </a:p>
           <a:p>
             <a:r>
-              <a:t>New pilot code freeze: d5f4e89. Configuration: configs/attacks/scheme_extension_pilot.yaml. Sources: experiments/scheme_extension_pilot/{results_summary,paired_uncertainty,equivalence_sensitivity,native_utility}.csv. SCface protocol and pilot freeze: 69a93e4; sources under experiments/scface_multiexposure and experiments/scface_scheme_extension_pilot. One-seed CPU pilots, 120-epoch cap; not a controlled ranking against earlier 400-epoch, three-seed studies. See figure_appendix.pdf for all figures, including native matching and uncertainty. Follow-up: experiments/scheme_followup_2026-09-18; 216 endpoints, two identity partitions, three model seeds. Pre-execution source/config hashes: execution_manifest.json; base commit 4352eeb, dirty working tree recorded. Primary sign-flip tests: Holm family 8; native gallery-label permutations: Holm family 12.</a:t>
+              <a:t>New pilot code freeze: d5f4e89. Configuration: configs/attacks/scheme_extension_pilot.yaml. Sources: experiments/scheme_extension_pilot/{results_summary,paired_uncertainty,equivalence_sensitivity,native_utility}.csv. SCface protocol and pilot freeze: 69a93e4; sources under experiments/scface_multiexposure and experiments/scface_scheme_extension_pilot. One-seed CPU pilots, 120-epoch cap; not a controlled ranking against earlier 400-epoch, three-seed studies. See figure_appendix.pdf for all figures, including native matching and uncertainty. Follow-up: experiments/scheme_followup_2026-09-18; 216 endpoints, two identity partitions, three model seeds. Pre-execution source/config hashes: execution_manifest.json; base commit 4352eeb, dirty working tree recorded. Primary sign-flip tests: Holm family 8; native gallery-label permutations: Holm family 12. Independent-pool follow-up: experiments/pool_replication_2026-09-19; 24 cells, 144 fits, 72 prediction-mean evaluations; source snapshots and input hashes recorded. Three-pool intervals are pointwise, not corrected significance tests. Full-text comparison uses the author's thesis section 5.4.</a:t>
             </a:r>
           </a:p>
         </p:txBody>
@@ -611,7 +613,177 @@
           </a:p>
           <a:p>
             <a:r>
-              <a:t>New pilot code freeze: d5f4e89. Configuration: configs/attacks/scheme_extension_pilot.yaml. Sources: experiments/scheme_extension_pilot/{results_summary,paired_uncertainty,equivalence_sensitivity,native_utility}.csv. SCface protocol and pilot freeze: 69a93e4; sources under experiments/scface_multiexposure and experiments/scface_scheme_extension_pilot. One-seed CPU pilots, 120-epoch cap; not a controlled ranking against earlier 400-epoch, three-seed studies. See figure_appendix.pdf for all figures, including native matching and uncertainty. Follow-up: experiments/scheme_followup_2026-09-18; 216 endpoints, two identity partitions, three model seeds. Pre-execution source/config hashes: execution_manifest.json; base commit 4352eeb, dirty working tree recorded. Primary sign-flip tests: Holm family 8; native gallery-label permutations: Holm family 12.</a:t>
+              <a:t>New pilot code freeze: d5f4e89. Configuration: configs/attacks/scheme_extension_pilot.yaml. Sources: experiments/scheme_extension_pilot/{results_summary,paired_uncertainty,equivalence_sensitivity,native_utility}.csv. SCface protocol and pilot freeze: 69a93e4; sources under experiments/scface_multiexposure and experiments/scface_scheme_extension_pilot. One-seed CPU pilots, 120-epoch cap; not a controlled ranking against earlier 400-epoch, three-seed studies. See figure_appendix.pdf for all figures, including native matching and uncertainty. Follow-up: experiments/scheme_followup_2026-09-18; 216 endpoints, two identity partitions, three model seeds. Pre-execution source/config hashes: execution_manifest.json; base commit 4352eeb, dirty working tree recorded. Primary sign-flip tests: Holm family 8; native gallery-label permutations: Holm family 12. Independent-pool follow-up: experiments/pool_replication_2026-09-19; 24 cells, 144 fits, 72 prediction-mean evaluations; source snapshots and input hashes recorded. Three-pool intervals are pointwise, not corrected significance tests. Full-text comparison uses the author's thesis section 5.4.</a:t>
+            </a:r>
+          </a:p>
+        </p:txBody>
+      </p:sp>
+      <p:sp>
+        <p:nvSpPr>
+          <p:cNvPr id="4" name="Slide Number Placeholder 3"/>
+          <p:cNvSpPr>
+            <a:spLocks noGrp="1"/>
+          </p:cNvSpPr>
+          <p:nvPr>
+            <p:ph type="sldNum" idx="5" sz="quarter"/>
+          </p:nvPr>
+        </p:nvSpPr>
+        <p:spPr/>
+      </p:sp>
+    </p:spTree>
+  </p:cSld>
+  <p:clrMapOvr>
+    <a:masterClrMapping/>
+  </p:clrMapOvr>
+</p:notes>
+</file>
+
+<file path=ppt/notesSlides/notesSlide11.xml><?xml version="1.0" encoding="utf-8"?>
+<p:notes xmlns:a="http://schemas.openxmlformats.org/drawingml/2006/main" xmlns:p="http://schemas.openxmlformats.org/presentationml/2006/main" xmlns:r="http://schemas.openxmlformats.org/officeDocument/2006/relationships">
+  <p:cSld>
+    <p:spTree>
+      <p:nvGrpSpPr>
+        <p:cNvPr id="1" name=""/>
+        <p:cNvGrpSpPr/>
+        <p:nvPr/>
+      </p:nvGrpSpPr>
+      <p:grpSpPr>
+        <a:xfrm>
+          <a:off x="0" y="0"/>
+          <a:ext cx="0" cy="0"/>
+          <a:chOff x="0" y="0"/>
+          <a:chExt cx="0" cy="0"/>
+        </a:xfrm>
+      </p:grpSpPr>
+      <p:sp>
+        <p:nvSpPr>
+          <p:cNvPr id="2" name="Slide Image Placeholder 1"/>
+          <p:cNvSpPr>
+            <a:spLocks noGrp="1"/>
+          </p:cNvSpPr>
+          <p:nvPr>
+            <p:ph type="sldImg" idx="2"/>
+          </p:nvPr>
+        </p:nvSpPr>
+        <p:spPr/>
+      </p:sp>
+      <p:sp>
+        <p:nvSpPr>
+          <p:cNvPr id="3" name="Notes Placeholder 2"/>
+          <p:cNvSpPr>
+            <a:spLocks noGrp="1"/>
+          </p:cNvSpPr>
+          <p:nvPr>
+            <p:ph type="body" idx="3" sz="quarter"/>
+          </p:nvPr>
+        </p:nvSpPr>
+        <p:spPr/>
+        <p:txBody>
+          <a:bodyPr/>
+          <a:lstStyle/>
+          <a:p>
+            <a:r>
+              <a:t>Evidence baseline: commit 655ae1ecc2c9fc0aa80c828fe0303753296f66df. FEI run recorded base commit d1e4ceb3f975fb47d9a8321c47484bb1411f5239 with FEI additions uncommitted.</a:t>
+            </a:r>
+          </a:p>
+          <a:p>
+            <a:r>
+              <a:t>Sources: experiments/cross_dataset_key_pool_summary.csv; experiments/fei_multiexposure/README.md; experiments/mobio_mechanism_controls/results_summary.csv; experiments/mobio_correlation_controls/results_summary.csv.</a:t>
+            </a:r>
+          </a:p>
+          <a:p>
+            <a:r>
+              <a:t>Configuration: configs/attacks/fei_key_pool_boundary.yaml. See reports/figures/README.md for figure captions and docs/ROADMAP.md for pending gates. Diagram symbols are schematic, not biometric examples.</a:t>
+            </a:r>
+          </a:p>
+          <a:p>
+            <a:r>
+              <a:t>New pilot code freeze: d5f4e89. Configuration: configs/attacks/scheme_extension_pilot.yaml. Sources: experiments/scheme_extension_pilot/{results_summary,paired_uncertainty,equivalence_sensitivity,native_utility}.csv. SCface protocol and pilot freeze: 69a93e4; sources under experiments/scface_multiexposure and experiments/scface_scheme_extension_pilot. One-seed CPU pilots, 120-epoch cap; not a controlled ranking against earlier 400-epoch, three-seed studies. See figure_appendix.pdf for all figures, including native matching and uncertainty. Follow-up: experiments/scheme_followup_2026-09-18; 216 endpoints, two identity partitions, three model seeds. Pre-execution source/config hashes: execution_manifest.json; base commit 4352eeb, dirty working tree recorded. Primary sign-flip tests: Holm family 8; native gallery-label permutations: Holm family 12. Independent-pool follow-up: experiments/pool_replication_2026-09-19; 24 cells, 144 fits, 72 prediction-mean evaluations; source snapshots and input hashes recorded. Three-pool intervals are pointwise, not corrected significance tests. Full-text comparison uses the author's thesis section 5.4.</a:t>
+            </a:r>
+          </a:p>
+        </p:txBody>
+      </p:sp>
+      <p:sp>
+        <p:nvSpPr>
+          <p:cNvPr id="4" name="Slide Number Placeholder 3"/>
+          <p:cNvSpPr>
+            <a:spLocks noGrp="1"/>
+          </p:cNvSpPr>
+          <p:nvPr>
+            <p:ph type="sldNum" idx="5" sz="quarter"/>
+          </p:nvPr>
+        </p:nvSpPr>
+        <p:spPr/>
+      </p:sp>
+    </p:spTree>
+  </p:cSld>
+  <p:clrMapOvr>
+    <a:masterClrMapping/>
+  </p:clrMapOvr>
+</p:notes>
+</file>
+
+<file path=ppt/notesSlides/notesSlide12.xml><?xml version="1.0" encoding="utf-8"?>
+<p:notes xmlns:a="http://schemas.openxmlformats.org/drawingml/2006/main" xmlns:p="http://schemas.openxmlformats.org/presentationml/2006/main" xmlns:r="http://schemas.openxmlformats.org/officeDocument/2006/relationships">
+  <p:cSld>
+    <p:spTree>
+      <p:nvGrpSpPr>
+        <p:cNvPr id="1" name=""/>
+        <p:cNvGrpSpPr/>
+        <p:nvPr/>
+      </p:nvGrpSpPr>
+      <p:grpSpPr>
+        <a:xfrm>
+          <a:off x="0" y="0"/>
+          <a:ext cx="0" cy="0"/>
+          <a:chOff x="0" y="0"/>
+          <a:chExt cx="0" cy="0"/>
+        </a:xfrm>
+      </p:grpSpPr>
+      <p:sp>
+        <p:nvSpPr>
+          <p:cNvPr id="2" name="Slide Image Placeholder 1"/>
+          <p:cNvSpPr>
+            <a:spLocks noGrp="1"/>
+          </p:cNvSpPr>
+          <p:nvPr>
+            <p:ph type="sldImg" idx="2"/>
+          </p:nvPr>
+        </p:nvSpPr>
+        <p:spPr/>
+      </p:sp>
+      <p:sp>
+        <p:nvSpPr>
+          <p:cNvPr id="3" name="Notes Placeholder 2"/>
+          <p:cNvSpPr>
+            <a:spLocks noGrp="1"/>
+          </p:cNvSpPr>
+          <p:nvPr>
+            <p:ph type="body" idx="3" sz="quarter"/>
+          </p:nvPr>
+        </p:nvSpPr>
+        <p:spPr/>
+        <p:txBody>
+          <a:bodyPr/>
+          <a:lstStyle/>
+          <a:p>
+            <a:r>
+              <a:t>Evidence baseline: commit 655ae1ecc2c9fc0aa80c828fe0303753296f66df. FEI run recorded base commit d1e4ceb3f975fb47d9a8321c47484bb1411f5239 with FEI additions uncommitted.</a:t>
+            </a:r>
+          </a:p>
+          <a:p>
+            <a:r>
+              <a:t>Sources: experiments/cross_dataset_key_pool_summary.csv; experiments/fei_multiexposure/README.md; experiments/mobio_mechanism_controls/results_summary.csv; experiments/mobio_correlation_controls/results_summary.csv.</a:t>
+            </a:r>
+          </a:p>
+          <a:p>
+            <a:r>
+              <a:t>Configuration: configs/attacks/fei_key_pool_boundary.yaml. See reports/figures/README.md for figure captions and docs/ROADMAP.md for pending gates. Diagram symbols are schematic, not biometric examples.</a:t>
+            </a:r>
+          </a:p>
+          <a:p>
+            <a:r>
+              <a:t>New pilot code freeze: d5f4e89. Configuration: configs/attacks/scheme_extension_pilot.yaml. Sources: experiments/scheme_extension_pilot/{results_summary,paired_uncertainty,equivalence_sensitivity,native_utility}.csv. SCface protocol and pilot freeze: 69a93e4; sources under experiments/scface_multiexposure and experiments/scface_scheme_extension_pilot. One-seed CPU pilots, 120-epoch cap; not a controlled ranking against earlier 400-epoch, three-seed studies. See figure_appendix.pdf for all figures, including native matching and uncertainty. Follow-up: experiments/scheme_followup_2026-09-18; 216 endpoints, two identity partitions, three model seeds. Pre-execution source/config hashes: execution_manifest.json; base commit 4352eeb, dirty working tree recorded. Primary sign-flip tests: Holm family 8; native gallery-label permutations: Holm family 12. Independent-pool follow-up: experiments/pool_replication_2026-09-19; 24 cells, 144 fits, 72 prediction-mean evaluations; source snapshots and input hashes recorded. Three-pool intervals are pointwise, not corrected significance tests. Full-text comparison uses the author's thesis section 5.4.</a:t>
             </a:r>
           </a:p>
         </p:txBody>
@@ -696,7 +868,7 @@
           </a:p>
           <a:p>
             <a:r>
-              <a:t>New pilot code freeze: d5f4e89. Configuration: configs/attacks/scheme_extension_pilot.yaml. Sources: experiments/scheme_extension_pilot/{results_summary,paired_uncertainty,equivalence_sensitivity,native_utility}.csv. SCface protocol and pilot freeze: 69a93e4; sources under experiments/scface_multiexposure and experiments/scface_scheme_extension_pilot. One-seed CPU pilots, 120-epoch cap; not a controlled ranking against earlier 400-epoch, three-seed studies. See figure_appendix.pdf for all figures, including native matching and uncertainty. Follow-up: experiments/scheme_followup_2026-09-18; 216 endpoints, two identity partitions, three model seeds. Pre-execution source/config hashes: execution_manifest.json; base commit 4352eeb, dirty working tree recorded. Primary sign-flip tests: Holm family 8; native gallery-label permutations: Holm family 12.</a:t>
+              <a:t>New pilot code freeze: d5f4e89. Configuration: configs/attacks/scheme_extension_pilot.yaml. Sources: experiments/scheme_extension_pilot/{results_summary,paired_uncertainty,equivalence_sensitivity,native_utility}.csv. SCface protocol and pilot freeze: 69a93e4; sources under experiments/scface_multiexposure and experiments/scface_scheme_extension_pilot. One-seed CPU pilots, 120-epoch cap; not a controlled ranking against earlier 400-epoch, three-seed studies. See figure_appendix.pdf for all figures, including native matching and uncertainty. Follow-up: experiments/scheme_followup_2026-09-18; 216 endpoints, two identity partitions, three model seeds. Pre-execution source/config hashes: execution_manifest.json; base commit 4352eeb, dirty working tree recorded. Primary sign-flip tests: Holm family 8; native gallery-label permutations: Holm family 12. Independent-pool follow-up: experiments/pool_replication_2026-09-19; 24 cells, 144 fits, 72 prediction-mean evaluations; source snapshots and input hashes recorded. Three-pool intervals are pointwise, not corrected significance tests. Full-text comparison uses the author's thesis section 5.4.</a:t>
             </a:r>
           </a:p>
         </p:txBody>
@@ -781,7 +953,7 @@
           </a:p>
           <a:p>
             <a:r>
-              <a:t>New pilot code freeze: d5f4e89. Configuration: configs/attacks/scheme_extension_pilot.yaml. Sources: experiments/scheme_extension_pilot/{results_summary,paired_uncertainty,equivalence_sensitivity,native_utility}.csv. SCface protocol and pilot freeze: 69a93e4; sources under experiments/scface_multiexposure and experiments/scface_scheme_extension_pilot. One-seed CPU pilots, 120-epoch cap; not a controlled ranking against earlier 400-epoch, three-seed studies. See figure_appendix.pdf for all figures, including native matching and uncertainty. Follow-up: experiments/scheme_followup_2026-09-18; 216 endpoints, two identity partitions, three model seeds. Pre-execution source/config hashes: execution_manifest.json; base commit 4352eeb, dirty working tree recorded. Primary sign-flip tests: Holm family 8; native gallery-label permutations: Holm family 12.</a:t>
+              <a:t>New pilot code freeze: d5f4e89. Configuration: configs/attacks/scheme_extension_pilot.yaml. Sources: experiments/scheme_extension_pilot/{results_summary,paired_uncertainty,equivalence_sensitivity,native_utility}.csv. SCface protocol and pilot freeze: 69a93e4; sources under experiments/scface_multiexposure and experiments/scface_scheme_extension_pilot. One-seed CPU pilots, 120-epoch cap; not a controlled ranking against earlier 400-epoch, three-seed studies. See figure_appendix.pdf for all figures, including native matching and uncertainty. Follow-up: experiments/scheme_followup_2026-09-18; 216 endpoints, two identity partitions, three model seeds. Pre-execution source/config hashes: execution_manifest.json; base commit 4352eeb, dirty working tree recorded. Primary sign-flip tests: Holm family 8; native gallery-label permutations: Holm family 12. Independent-pool follow-up: experiments/pool_replication_2026-09-19; 24 cells, 144 fits, 72 prediction-mean evaluations; source snapshots and input hashes recorded. Three-pool intervals are pointwise, not corrected significance tests. Full-text comparison uses the author's thesis section 5.4.</a:t>
             </a:r>
           </a:p>
         </p:txBody>
@@ -866,7 +1038,7 @@
           </a:p>
           <a:p>
             <a:r>
-              <a:t>New pilot code freeze: d5f4e89. Configuration: configs/attacks/scheme_extension_pilot.yaml. Sources: experiments/scheme_extension_pilot/{results_summary,paired_uncertainty,equivalence_sensitivity,native_utility}.csv. SCface protocol and pilot freeze: 69a93e4; sources under experiments/scface_multiexposure and experiments/scface_scheme_extension_pilot. One-seed CPU pilots, 120-epoch cap; not a controlled ranking against earlier 400-epoch, three-seed studies. See figure_appendix.pdf for all figures, including native matching and uncertainty. Follow-up: experiments/scheme_followup_2026-09-18; 216 endpoints, two identity partitions, three model seeds. Pre-execution source/config hashes: execution_manifest.json; base commit 4352eeb, dirty working tree recorded. Primary sign-flip tests: Holm family 8; native gallery-label permutations: Holm family 12.</a:t>
+              <a:t>New pilot code freeze: d5f4e89. Configuration: configs/attacks/scheme_extension_pilot.yaml. Sources: experiments/scheme_extension_pilot/{results_summary,paired_uncertainty,equivalence_sensitivity,native_utility}.csv. SCface protocol and pilot freeze: 69a93e4; sources under experiments/scface_multiexposure and experiments/scface_scheme_extension_pilot. One-seed CPU pilots, 120-epoch cap; not a controlled ranking against earlier 400-epoch, three-seed studies. See figure_appendix.pdf for all figures, including native matching and uncertainty. Follow-up: experiments/scheme_followup_2026-09-18; 216 endpoints, two identity partitions, three model seeds. Pre-execution source/config hashes: execution_manifest.json; base commit 4352eeb, dirty working tree recorded. Primary sign-flip tests: Holm family 8; native gallery-label permutations: Holm family 12. Independent-pool follow-up: experiments/pool_replication_2026-09-19; 24 cells, 144 fits, 72 prediction-mean evaluations; source snapshots and input hashes recorded. Three-pool intervals are pointwise, not corrected significance tests. Full-text comparison uses the author's thesis section 5.4.</a:t>
             </a:r>
           </a:p>
         </p:txBody>
@@ -951,7 +1123,7 @@
           </a:p>
           <a:p>
             <a:r>
-              <a:t>New pilot code freeze: d5f4e89. Configuration: configs/attacks/scheme_extension_pilot.yaml. Sources: experiments/scheme_extension_pilot/{results_summary,paired_uncertainty,equivalence_sensitivity,native_utility}.csv. SCface protocol and pilot freeze: 69a93e4; sources under experiments/scface_multiexposure and experiments/scface_scheme_extension_pilot. One-seed CPU pilots, 120-epoch cap; not a controlled ranking against earlier 400-epoch, three-seed studies. See figure_appendix.pdf for all figures, including native matching and uncertainty. Follow-up: experiments/scheme_followup_2026-09-18; 216 endpoints, two identity partitions, three model seeds. Pre-execution source/config hashes: execution_manifest.json; base commit 4352eeb, dirty working tree recorded. Primary sign-flip tests: Holm family 8; native gallery-label permutations: Holm family 12.</a:t>
+              <a:t>New pilot code freeze: d5f4e89. Configuration: configs/attacks/scheme_extension_pilot.yaml. Sources: experiments/scheme_extension_pilot/{results_summary,paired_uncertainty,equivalence_sensitivity,native_utility}.csv. SCface protocol and pilot freeze: 69a93e4; sources under experiments/scface_multiexposure and experiments/scface_scheme_extension_pilot. One-seed CPU pilots, 120-epoch cap; not a controlled ranking against earlier 400-epoch, three-seed studies. See figure_appendix.pdf for all figures, including native matching and uncertainty. Follow-up: experiments/scheme_followup_2026-09-18; 216 endpoints, two identity partitions, three model seeds. Pre-execution source/config hashes: execution_manifest.json; base commit 4352eeb, dirty working tree recorded. Primary sign-flip tests: Holm family 8; native gallery-label permutations: Holm family 12. Independent-pool follow-up: experiments/pool_replication_2026-09-19; 24 cells, 144 fits, 72 prediction-mean evaluations; source snapshots and input hashes recorded. Three-pool intervals are pointwise, not corrected significance tests. Full-text comparison uses the author's thesis section 5.4.</a:t>
             </a:r>
           </a:p>
         </p:txBody>
@@ -1036,7 +1208,7 @@
           </a:p>
           <a:p>
             <a:r>
-              <a:t>New pilot code freeze: d5f4e89. Configuration: configs/attacks/scheme_extension_pilot.yaml. Sources: experiments/scheme_extension_pilot/{results_summary,paired_uncertainty,equivalence_sensitivity,native_utility}.csv. SCface protocol and pilot freeze: 69a93e4; sources under experiments/scface_multiexposure and experiments/scface_scheme_extension_pilot. One-seed CPU pilots, 120-epoch cap; not a controlled ranking against earlier 400-epoch, three-seed studies. See figure_appendix.pdf for all figures, including native matching and uncertainty. Follow-up: experiments/scheme_followup_2026-09-18; 216 endpoints, two identity partitions, three model seeds. Pre-execution source/config hashes: execution_manifest.json; base commit 4352eeb, dirty working tree recorded. Primary sign-flip tests: Holm family 8; native gallery-label permutations: Holm family 12.</a:t>
+              <a:t>New pilot code freeze: d5f4e89. Configuration: configs/attacks/scheme_extension_pilot.yaml. Sources: experiments/scheme_extension_pilot/{results_summary,paired_uncertainty,equivalence_sensitivity,native_utility}.csv. SCface protocol and pilot freeze: 69a93e4; sources under experiments/scface_multiexposure and experiments/scface_scheme_extension_pilot. One-seed CPU pilots, 120-epoch cap; not a controlled ranking against earlier 400-epoch, three-seed studies. See figure_appendix.pdf for all figures, including native matching and uncertainty. Follow-up: experiments/scheme_followup_2026-09-18; 216 endpoints, two identity partitions, three model seeds. Pre-execution source/config hashes: execution_manifest.json; base commit 4352eeb, dirty working tree recorded. Primary sign-flip tests: Holm family 8; native gallery-label permutations: Holm family 12. Independent-pool follow-up: experiments/pool_replication_2026-09-19; 24 cells, 144 fits, 72 prediction-mean evaluations; source snapshots and input hashes recorded. Three-pool intervals are pointwise, not corrected significance tests. Full-text comparison uses the author's thesis section 5.4.</a:t>
             </a:r>
           </a:p>
         </p:txBody>
@@ -1121,7 +1293,7 @@
           </a:p>
           <a:p>
             <a:r>
-              <a:t>New pilot code freeze: d5f4e89. Configuration: configs/attacks/scheme_extension_pilot.yaml. Sources: experiments/scheme_extension_pilot/{results_summary,paired_uncertainty,equivalence_sensitivity,native_utility}.csv. SCface protocol and pilot freeze: 69a93e4; sources under experiments/scface_multiexposure and experiments/scface_scheme_extension_pilot. One-seed CPU pilots, 120-epoch cap; not a controlled ranking against earlier 400-epoch, three-seed studies. See figure_appendix.pdf for all figures, including native matching and uncertainty. Follow-up: experiments/scheme_followup_2026-09-18; 216 endpoints, two identity partitions, three model seeds. Pre-execution source/config hashes: execution_manifest.json; base commit 4352eeb, dirty working tree recorded. Primary sign-flip tests: Holm family 8; native gallery-label permutations: Holm family 12.</a:t>
+              <a:t>New pilot code freeze: d5f4e89. Configuration: configs/attacks/scheme_extension_pilot.yaml. Sources: experiments/scheme_extension_pilot/{results_summary,paired_uncertainty,equivalence_sensitivity,native_utility}.csv. SCface protocol and pilot freeze: 69a93e4; sources under experiments/scface_multiexposure and experiments/scface_scheme_extension_pilot. One-seed CPU pilots, 120-epoch cap; not a controlled ranking against earlier 400-epoch, three-seed studies. See figure_appendix.pdf for all figures, including native matching and uncertainty. Follow-up: experiments/scheme_followup_2026-09-18; 216 endpoints, two identity partitions, three model seeds. Pre-execution source/config hashes: execution_manifest.json; base commit 4352eeb, dirty working tree recorded. Primary sign-flip tests: Holm family 8; native gallery-label permutations: Holm family 12. Independent-pool follow-up: experiments/pool_replication_2026-09-19; 24 cells, 144 fits, 72 prediction-mean evaluations; source snapshots and input hashes recorded. Three-pool intervals are pointwise, not corrected significance tests. Full-text comparison uses the author's thesis section 5.4.</a:t>
             </a:r>
           </a:p>
         </p:txBody>
@@ -1206,7 +1378,7 @@
           </a:p>
           <a:p>
             <a:r>
-              <a:t>New pilot code freeze: d5f4e89. Configuration: configs/attacks/scheme_extension_pilot.yaml. Sources: experiments/scheme_extension_pilot/{results_summary,paired_uncertainty,equivalence_sensitivity,native_utility}.csv. SCface protocol and pilot freeze: 69a93e4; sources under experiments/scface_multiexposure and experiments/scface_scheme_extension_pilot. One-seed CPU pilots, 120-epoch cap; not a controlled ranking against earlier 400-epoch, three-seed studies. See figure_appendix.pdf for all figures, including native matching and uncertainty. Follow-up: experiments/scheme_followup_2026-09-18; 216 endpoints, two identity partitions, three model seeds. Pre-execution source/config hashes: execution_manifest.json; base commit 4352eeb, dirty working tree recorded. Primary sign-flip tests: Holm family 8; native gallery-label permutations: Holm family 12.</a:t>
+              <a:t>New pilot code freeze: d5f4e89. Configuration: configs/attacks/scheme_extension_pilot.yaml. Sources: experiments/scheme_extension_pilot/{results_summary,paired_uncertainty,equivalence_sensitivity,native_utility}.csv. SCface protocol and pilot freeze: 69a93e4; sources under experiments/scface_multiexposure and experiments/scface_scheme_extension_pilot. One-seed CPU pilots, 120-epoch cap; not a controlled ranking against earlier 400-epoch, three-seed studies. See figure_appendix.pdf for all figures, including native matching and uncertainty. Follow-up: experiments/scheme_followup_2026-09-18; 216 endpoints, two identity partitions, three model seeds. Pre-execution source/config hashes: execution_manifest.json; base commit 4352eeb, dirty working tree recorded. Primary sign-flip tests: Holm family 8; native gallery-label permutations: Holm family 12. Independent-pool follow-up: experiments/pool_replication_2026-09-19; 24 cells, 144 fits, 72 prediction-mean evaluations; source snapshots and input hashes recorded. Three-pool intervals are pointwise, not corrected significance tests. Full-text comparison uses the author's thesis section 5.4.</a:t>
             </a:r>
           </a:p>
         </p:txBody>
@@ -1291,7 +1463,7 @@
           </a:p>
           <a:p>
             <a:r>
-              <a:t>New pilot code freeze: d5f4e89. Configuration: configs/attacks/scheme_extension_pilot.yaml. Sources: experiments/scheme_extension_pilot/{results_summary,paired_uncertainty,equivalence_sensitivity,native_utility}.csv. SCface protocol and pilot freeze: 69a93e4; sources under experiments/scface_multiexposure and experiments/scface_scheme_extension_pilot. One-seed CPU pilots, 120-epoch cap; not a controlled ranking against earlier 400-epoch, three-seed studies. See figure_appendix.pdf for all figures, including native matching and uncertainty. Follow-up: experiments/scheme_followup_2026-09-18; 216 endpoints, two identity partitions, three model seeds. Pre-execution source/config hashes: execution_manifest.json; base commit 4352eeb, dirty working tree recorded. Primary sign-flip tests: Holm family 8; native gallery-label permutations: Holm family 12.</a:t>
+              <a:t>New pilot code freeze: d5f4e89. Configuration: configs/attacks/scheme_extension_pilot.yaml. Sources: experiments/scheme_extension_pilot/{results_summary,paired_uncertainty,equivalence_sensitivity,native_utility}.csv. SCface protocol and pilot freeze: 69a93e4; sources under experiments/scface_multiexposure and experiments/scface_scheme_extension_pilot. One-seed CPU pilots, 120-epoch cap; not a controlled ranking against earlier 400-epoch, three-seed studies. See figure_appendix.pdf for all figures, including native matching and uncertainty. Follow-up: experiments/scheme_followup_2026-09-18; 216 endpoints, two identity partitions, three model seeds. Pre-execution source/config hashes: execution_manifest.json; base commit 4352eeb, dirty working tree recorded. Primary sign-flip tests: Holm family 8; native gallery-label permutations: Holm family 12. Independent-pool follow-up: experiments/pool_replication_2026-09-19; 24 cells, 144 fits, 72 prediction-mean evaluations; source snapshots and input hashes recorded. Three-pool intervals are pointwise, not corrected significance tests. Full-text comparison uses the author's thesis section 5.4.</a:t>
             </a:r>
           </a:p>
         </p:txBody>
@@ -4376,7 +4548,7 @@
               </a:defRPr>
             </a:pPr>
             <a:r>
-              <a:t>Research review draft | 18 September 2026 | 1/10</a:t>
+              <a:t>Research review draft | 19 September 2026 | 1/12</a:t>
             </a:r>
           </a:p>
         </p:txBody>
@@ -4530,7 +4702,7 @@
               </a:defRPr>
             </a:pPr>
             <a:r>
-              <a:t>Boundary location changes with the dataset and identity partition.</a:t>
+              <a:t>Pool draws matter; a simple prediction-mean baseline is competitive.</a:t>
             </a:r>
           </a:p>
         </p:txBody>
@@ -4572,7 +4744,7 @@
               </a:defRPr>
             </a:pPr>
             <a:r>
-              <a:t>Four datasets; hidden-key protocols; matched MOBIO/FEI follow-up with 216 trained endpoints.</a:t>
+              <a:t>MOBIO/FEI: 216 earlier trained endpoints; 144 new fits plus 72 prediction-mean evaluations.</a:t>
             </a:r>
           </a:p>
         </p:txBody>
@@ -4674,7 +4846,7 @@
               </a:defRPr>
             </a:pPr>
             <a:r>
-              <a:t>Research review draft | 18 September 2026 | 10/10</a:t>
+              <a:t>Research review draft | 19 September 2026 | 10/12</a:t>
             </a:r>
           </a:p>
         </p:txBody>
@@ -4741,6 +4913,342 @@
             </a:pPr>
             <a:r>
               <a:t>Original primary family unchanged. All 48 contrasts, including significant losses, are reported separately from historical exploration.</a:t>
+            </a:r>
+          </a:p>
+        </p:txBody>
+      </p:sp>
+    </p:spTree>
+  </p:cSld>
+  <p:clrMapOvr>
+    <a:masterClrMapping/>
+  </p:clrMapOvr>
+</p:sld>
+</file>
+
+<file path=ppt/slides/slide11.xml><?xml version="1.0" encoding="utf-8"?>
+<p:sld xmlns:a="http://schemas.openxmlformats.org/drawingml/2006/main" xmlns:p="http://schemas.openxmlformats.org/presentationml/2006/main" xmlns:r="http://schemas.openxmlformats.org/officeDocument/2006/relationships">
+  <p:cSld>
+    <p:spTree>
+      <p:nvGrpSpPr>
+        <p:cNvPr id="1" name=""/>
+        <p:cNvGrpSpPr/>
+        <p:nvPr/>
+      </p:nvGrpSpPr>
+      <p:grpSpPr/>
+      <p:sp>
+        <p:nvSpPr>
+          <p:cNvPr id="2" name="TextBox 1"/>
+          <p:cNvSpPr txBox="1"/>
+          <p:nvPr/>
+        </p:nvSpPr>
+        <p:spPr>
+          <a:xfrm>
+            <a:off x="548640" y="274320"/>
+            <a:ext cx="11064240" cy="548640"/>
+          </a:xfrm>
+          <a:prstGeom prst="rect">
+            <a:avLst/>
+          </a:prstGeom>
+          <a:noFill/>
+        </p:spPr>
+        <p:txBody>
+          <a:bodyPr wrap="none" lIns="0" rIns="0" tIns="0" bIns="0">
+            <a:spAutoFit/>
+          </a:bodyPr>
+          <a:lstStyle/>
+          <a:p>
+            <a:pPr>
+              <a:lnSpc>
+                <a:spcPct val="140000"/>
+              </a:lnSpc>
+              <a:spcAft>
+                <a:spcPts val="0"/>
+              </a:spcAft>
+              <a:defRPr sz="2500" b="1">
+                <a:solidFill>
+                  <a:srgbClr val="222222"/>
+                </a:solidFill>
+                <a:latin typeface="Times New Roman"/>
+              </a:defRPr>
+            </a:pPr>
+            <a:r>
+              <a:t>Four datasets, distinct evidence layers</a:t>
+            </a:r>
+          </a:p>
+        </p:txBody>
+      </p:sp>
+      <p:sp>
+        <p:nvSpPr>
+          <p:cNvPr id="3" name="TextBox 2"/>
+          <p:cNvSpPr txBox="1"/>
+          <p:nvPr/>
+        </p:nvSpPr>
+        <p:spPr>
+          <a:xfrm>
+            <a:off x="548640" y="6464808"/>
+            <a:ext cx="11064240" cy="274320"/>
+          </a:xfrm>
+          <a:prstGeom prst="rect">
+            <a:avLst/>
+          </a:prstGeom>
+          <a:noFill/>
+        </p:spPr>
+        <p:txBody>
+          <a:bodyPr wrap="none" lIns="0" rIns="0" tIns="0" bIns="0">
+            <a:spAutoFit/>
+          </a:bodyPr>
+          <a:lstStyle/>
+          <a:p>
+            <a:pPr>
+              <a:lnSpc>
+                <a:spcPct val="140000"/>
+              </a:lnSpc>
+              <a:spcAft>
+                <a:spcPts val="0"/>
+              </a:spcAft>
+              <a:defRPr sz="1100" b="0">
+                <a:solidFill>
+                  <a:srgbClr val="666666"/>
+                </a:solidFill>
+                <a:latin typeface="Times New Roman"/>
+              </a:defRPr>
+            </a:pPr>
+            <a:r>
+              <a:t>Research review draft | 19 September 2026 | 11/12</a:t>
+            </a:r>
+          </a:p>
+        </p:txBody>
+      </p:sp>
+      <p:pic>
+        <p:nvPicPr>
+          <p:cNvPr id="4" name="Picture 3" descr="fig_dataset_coverage.png"/>
+          <p:cNvPicPr>
+            <a:picLocks noChangeAspect="1"/>
+          </p:cNvPicPr>
+          <p:nvPr/>
+        </p:nvPicPr>
+        <p:blipFill>
+          <a:blip r:embed="rId2"/>
+          <a:stretch>
+            <a:fillRect/>
+          </a:stretch>
+        </p:blipFill>
+        <p:spPr>
+          <a:xfrm>
+            <a:off x="730091" y="960120"/>
+            <a:ext cx="10701337" cy="4892040"/>
+          </a:xfrm>
+          <a:prstGeom prst="rect">
+            <a:avLst/>
+          </a:prstGeom>
+        </p:spPr>
+      </p:pic>
+      <p:sp>
+        <p:nvSpPr>
+          <p:cNvPr id="5" name="TextBox 4"/>
+          <p:cNvSpPr txBox="1"/>
+          <p:nvPr/>
+        </p:nvSpPr>
+        <p:spPr>
+          <a:xfrm>
+            <a:off x="548640" y="6016752"/>
+            <a:ext cx="11064240" cy="365760"/>
+          </a:xfrm>
+          <a:prstGeom prst="rect">
+            <a:avLst/>
+          </a:prstGeom>
+          <a:noFill/>
+        </p:spPr>
+        <p:txBody>
+          <a:bodyPr wrap="none" lIns="0" rIns="0" tIns="0" bIns="0">
+            <a:spAutoFit/>
+          </a:bodyPr>
+          <a:lstStyle/>
+          <a:p>
+            <a:pPr>
+              <a:lnSpc>
+                <a:spcPct val="140000"/>
+              </a:lnSpc>
+              <a:spcAft>
+                <a:spcPts val="0"/>
+              </a:spcAft>
+              <a:defRPr sz="1200" b="0">
+                <a:solidFill>
+                  <a:srgbClr val="222222"/>
+                </a:solidFill>
+                <a:latin typeface="Times New Roman"/>
+              </a:defRPr>
+            </a:pPr>
+            <a:r>
+              <a:t>SCface remains supporting cross-camera evidence, not matched new-scheme confirmation. Missing cells are not zero accuracy.</a:t>
+            </a:r>
+          </a:p>
+        </p:txBody>
+      </p:sp>
+    </p:spTree>
+  </p:cSld>
+  <p:clrMapOvr>
+    <a:masterClrMapping/>
+  </p:clrMapOvr>
+</p:sld>
+</file>
+
+<file path=ppt/slides/slide12.xml><?xml version="1.0" encoding="utf-8"?>
+<p:sld xmlns:a="http://schemas.openxmlformats.org/drawingml/2006/main" xmlns:p="http://schemas.openxmlformats.org/presentationml/2006/main" xmlns:r="http://schemas.openxmlformats.org/officeDocument/2006/relationships">
+  <p:cSld>
+    <p:spTree>
+      <p:nvGrpSpPr>
+        <p:cNvPr id="1" name=""/>
+        <p:cNvGrpSpPr/>
+        <p:nvPr/>
+      </p:nvGrpSpPr>
+      <p:grpSpPr/>
+      <p:sp>
+        <p:nvSpPr>
+          <p:cNvPr id="2" name="TextBox 1"/>
+          <p:cNvSpPr txBox="1"/>
+          <p:nvPr/>
+        </p:nvSpPr>
+        <p:spPr>
+          <a:xfrm>
+            <a:off x="548640" y="274320"/>
+            <a:ext cx="11064240" cy="548640"/>
+          </a:xfrm>
+          <a:prstGeom prst="rect">
+            <a:avLst/>
+          </a:prstGeom>
+          <a:noFill/>
+        </p:spPr>
+        <p:txBody>
+          <a:bodyPr wrap="none" lIns="0" rIns="0" tIns="0" bIns="0">
+            <a:spAutoFit/>
+          </a:bodyPr>
+          <a:lstStyle/>
+          <a:p>
+            <a:pPr>
+              <a:lnSpc>
+                <a:spcPct val="140000"/>
+              </a:lnSpc>
+              <a:spcAft>
+                <a:spcPts val="0"/>
+              </a:spcAft>
+              <a:defRPr sz="2500" b="1">
+                <a:solidFill>
+                  <a:srgbClr val="222222"/>
+                </a:solidFill>
+                <a:latin typeface="Times New Roman"/>
+              </a:defRPr>
+            </a:pPr>
+            <a:r>
+              <a:t>Independent pools and a matched baseline</a:t>
+            </a:r>
+          </a:p>
+        </p:txBody>
+      </p:sp>
+      <p:sp>
+        <p:nvSpPr>
+          <p:cNvPr id="3" name="TextBox 2"/>
+          <p:cNvSpPr txBox="1"/>
+          <p:nvPr/>
+        </p:nvSpPr>
+        <p:spPr>
+          <a:xfrm>
+            <a:off x="548640" y="6464808"/>
+            <a:ext cx="11064240" cy="274320"/>
+          </a:xfrm>
+          <a:prstGeom prst="rect">
+            <a:avLst/>
+          </a:prstGeom>
+          <a:noFill/>
+        </p:spPr>
+        <p:txBody>
+          <a:bodyPr wrap="none" lIns="0" rIns="0" tIns="0" bIns="0">
+            <a:spAutoFit/>
+          </a:bodyPr>
+          <a:lstStyle/>
+          <a:p>
+            <a:pPr>
+              <a:lnSpc>
+                <a:spcPct val="140000"/>
+              </a:lnSpc>
+              <a:spcAft>
+                <a:spcPts val="0"/>
+              </a:spcAft>
+              <a:defRPr sz="1100" b="0">
+                <a:solidFill>
+                  <a:srgbClr val="666666"/>
+                </a:solidFill>
+                <a:latin typeface="Times New Roman"/>
+              </a:defRPr>
+            </a:pPr>
+            <a:r>
+              <a:t>Research review draft | 19 September 2026 | 12/12</a:t>
+            </a:r>
+          </a:p>
+        </p:txBody>
+      </p:sp>
+      <p:pic>
+        <p:nvPicPr>
+          <p:cNvPr id="4" name="Picture 3" descr="fig_pool_replication.png"/>
+          <p:cNvPicPr>
+            <a:picLocks noChangeAspect="1"/>
+          </p:cNvPicPr>
+          <p:nvPr/>
+        </p:nvPicPr>
+        <p:blipFill>
+          <a:blip r:embed="rId2"/>
+          <a:stretch>
+            <a:fillRect/>
+          </a:stretch>
+        </p:blipFill>
+        <p:spPr>
+          <a:xfrm>
+            <a:off x="1234871" y="960120"/>
+            <a:ext cx="9691777" cy="4892040"/>
+          </a:xfrm>
+          <a:prstGeom prst="rect">
+            <a:avLst/>
+          </a:prstGeom>
+        </p:spPr>
+      </p:pic>
+      <p:sp>
+        <p:nvSpPr>
+          <p:cNvPr id="5" name="TextBox 4"/>
+          <p:cNvSpPr txBox="1"/>
+          <p:nvPr/>
+        </p:nvSpPr>
+        <p:spPr>
+          <a:xfrm>
+            <a:off x="548640" y="6016752"/>
+            <a:ext cx="11064240" cy="365760"/>
+          </a:xfrm>
+          <a:prstGeom prst="rect">
+            <a:avLst/>
+          </a:prstGeom>
+          <a:noFill/>
+        </p:spPr>
+        <p:txBody>
+          <a:bodyPr wrap="none" lIns="0" rIns="0" tIns="0" bIns="0">
+            <a:spAutoFit/>
+          </a:bodyPr>
+          <a:lstStyle/>
+          <a:p>
+            <a:pPr>
+              <a:lnSpc>
+                <a:spcPct val="140000"/>
+              </a:lnSpc>
+              <a:spcAft>
+                <a:spcPts val="0"/>
+              </a:spcAft>
+              <a:defRPr sz="1200" b="0">
+                <a:solidFill>
+                  <a:srgbClr val="222222"/>
+                </a:solidFill>
+                <a:latin typeface="Times New Roman"/>
+              </a:defRPr>
+            </a:pPr>
+            <a:r>
+              <a:t>Three new pool draws: IoM gains persist; PolyProtect is variable. Input-pooling superiority is not established.</a:t>
             </a:r>
           </a:p>
         </p:txBody>
@@ -4842,7 +5350,7 @@
               </a:defRPr>
             </a:pPr>
             <a:r>
-              <a:t>Research review draft | 18 September 2026 | 2/10</a:t>
+              <a:t>Research review draft | 19 September 2026 | 2/12</a:t>
             </a:r>
           </a:p>
         </p:txBody>
@@ -5010,7 +5518,7 @@
               </a:defRPr>
             </a:pPr>
             <a:r>
-              <a:t>Research review draft | 18 September 2026 | 3/10</a:t>
+              <a:t>Research review draft | 19 September 2026 | 3/12</a:t>
             </a:r>
           </a:p>
         </p:txBody>
@@ -6303,7 +6811,7 @@
               </a:defRPr>
             </a:pPr>
             <a:r>
-              <a:t>Research review draft | 18 September 2026 | 4/10</a:t>
+              <a:t>Research review draft | 19 September 2026 | 4/12</a:t>
             </a:r>
           </a:p>
         </p:txBody>
@@ -6471,7 +6979,7 @@
               </a:defRPr>
             </a:pPr>
             <a:r>
-              <a:t>Research review draft | 18 September 2026 | 5/10</a:t>
+              <a:t>Research review draft | 19 September 2026 | 5/12</a:t>
             </a:r>
           </a:p>
         </p:txBody>
@@ -6639,7 +7147,7 @@
               </a:defRPr>
             </a:pPr>
             <a:r>
-              <a:t>Research review draft | 18 September 2026 | 6/10</a:t>
+              <a:t>Research review draft | 19 September 2026 | 6/12</a:t>
             </a:r>
           </a:p>
         </p:txBody>
@@ -6807,7 +7315,7 @@
               </a:defRPr>
             </a:pPr>
             <a:r>
-              <a:t>Research review draft | 18 September 2026 | 7/10</a:t>
+              <a:t>Research review draft | 19 September 2026 | 7/12</a:t>
             </a:r>
           </a:p>
         </p:txBody>
@@ -6975,7 +7483,7 @@
               </a:defRPr>
             </a:pPr>
             <a:r>
-              <a:t>Research review draft | 18 September 2026 | 8/10</a:t>
+              <a:t>Research review draft | 19 September 2026 | 8/12</a:t>
             </a:r>
           </a:p>
         </p:txBody>
@@ -7143,7 +7651,7 @@
               </a:defRPr>
             </a:pPr>
             <a:r>
-              <a:t>Research review draft | 18 September 2026 | 9/10</a:t>
+              <a:t>Research review draft | 19 September 2026 | 9/12</a:t>
             </a:r>
           </a:p>
         </p:txBody>

</xml_diff>

<commit_message>
Update finalized experiment report and plain-language page guide
</commit_message>
<xml_diff>
--- a/reports/slides/research_review.pptx
+++ b/reports/slides/research_review.pptx
@@ -17,6 +17,9 @@
     <p:sldId id="265" r:id="rId17"/>
     <p:sldId id="266" r:id="rId18"/>
     <p:sldId id="267" r:id="rId19"/>
+    <p:sldId id="268" r:id="rId20"/>
+    <p:sldId id="269" r:id="rId21"/>
+    <p:sldId id="270" r:id="rId22"/>
   </p:sldIdLst>
   <p:sldSz cx="12191999" cy="6858000" type="screen4x3"/>
   <p:notesSz cx="6858000" cy="9144000"/>
@@ -724,6 +727,261 @@
 </file>
 
 <file path=ppt/notesSlides/notesSlide12.xml><?xml version="1.0" encoding="utf-8"?>
+<p:notes xmlns:a="http://schemas.openxmlformats.org/drawingml/2006/main" xmlns:p="http://schemas.openxmlformats.org/presentationml/2006/main" xmlns:r="http://schemas.openxmlformats.org/officeDocument/2006/relationships">
+  <p:cSld>
+    <p:spTree>
+      <p:nvGrpSpPr>
+        <p:cNvPr id="1" name=""/>
+        <p:cNvGrpSpPr/>
+        <p:nvPr/>
+      </p:nvGrpSpPr>
+      <p:grpSpPr>
+        <a:xfrm>
+          <a:off x="0" y="0"/>
+          <a:ext cx="0" cy="0"/>
+          <a:chOff x="0" y="0"/>
+          <a:chExt cx="0" cy="0"/>
+        </a:xfrm>
+      </p:grpSpPr>
+      <p:sp>
+        <p:nvSpPr>
+          <p:cNvPr id="2" name="Slide Image Placeholder 1"/>
+          <p:cNvSpPr>
+            <a:spLocks noGrp="1"/>
+          </p:cNvSpPr>
+          <p:nvPr>
+            <p:ph type="sldImg" idx="2"/>
+          </p:nvPr>
+        </p:nvSpPr>
+        <p:spPr/>
+      </p:sp>
+      <p:sp>
+        <p:nvSpPr>
+          <p:cNvPr id="3" name="Notes Placeholder 2"/>
+          <p:cNvSpPr>
+            <a:spLocks noGrp="1"/>
+          </p:cNvSpPr>
+          <p:nvPr>
+            <p:ph type="body" idx="3" sz="quarter"/>
+          </p:nvPr>
+        </p:nvSpPr>
+        <p:spPr/>
+        <p:txBody>
+          <a:bodyPr/>
+          <a:lstStyle/>
+          <a:p>
+            <a:r>
+              <a:t>Evidence baseline: commit 655ae1ecc2c9fc0aa80c828fe0303753296f66df. FEI run recorded base commit d1e4ceb3f975fb47d9a8321c47484bb1411f5239 with FEI additions uncommitted.</a:t>
+            </a:r>
+          </a:p>
+          <a:p>
+            <a:r>
+              <a:t>Sources: experiments/cross_dataset_key_pool_summary.csv; experiments/fei_multiexposure/README.md; experiments/mobio_mechanism_controls/results_summary.csv; experiments/mobio_correlation_controls/results_summary.csv.</a:t>
+            </a:r>
+          </a:p>
+          <a:p>
+            <a:r>
+              <a:t>Configuration: configs/attacks/fei_key_pool_boundary.yaml. See reports/figures/README.md for figure captions and docs/ROADMAP.md for pending gates. Diagram symbols are schematic, not biometric examples.</a:t>
+            </a:r>
+          </a:p>
+          <a:p>
+            <a:r>
+              <a:t>New pilot code freeze: d5f4e89. Configuration: configs/attacks/scheme_extension_pilot.yaml. Sources: experiments/scheme_extension_pilot/{results_summary,paired_uncertainty,equivalence_sensitivity,native_utility}.csv. SCface protocol and pilot freeze: 69a93e4; sources under experiments/scface_multiexposure and experiments/scface_scheme_extension_pilot. One-seed CPU pilots, 120-epoch cap; not a controlled ranking against earlier 400-epoch, three-seed studies. See figure_appendix.pdf for all figures, including native matching and uncertainty. Follow-up: experiments/scheme_followup_2026-09-18; 216 endpoints, two identity partitions, three model seeds. Pre-execution source/config hashes: execution_manifest.json; base commit 4352eeb, dirty working tree recorded. Primary sign-flip tests: Holm family 8; native gallery-label permutations: Holm family 12. Independent-pool follow-up: experiments/pool_replication_2026-09-19; 24 cells, 144 fits, 72 prediction-mean evaluations; source snapshots and input hashes recorded. Three-pool intervals are pointwise, not corrected significance tests. Full-text comparison uses the author's thesis section 5.4.</a:t>
+            </a:r>
+          </a:p>
+        </p:txBody>
+      </p:sp>
+      <p:sp>
+        <p:nvSpPr>
+          <p:cNvPr id="4" name="Slide Number Placeholder 3"/>
+          <p:cNvSpPr>
+            <a:spLocks noGrp="1"/>
+          </p:cNvSpPr>
+          <p:nvPr>
+            <p:ph type="sldNum" idx="5" sz="quarter"/>
+          </p:nvPr>
+        </p:nvSpPr>
+        <p:spPr/>
+      </p:sp>
+    </p:spTree>
+  </p:cSld>
+  <p:clrMapOvr>
+    <a:masterClrMapping/>
+  </p:clrMapOvr>
+</p:notes>
+</file>
+
+<file path=ppt/notesSlides/notesSlide13.xml><?xml version="1.0" encoding="utf-8"?>
+<p:notes xmlns:a="http://schemas.openxmlformats.org/drawingml/2006/main" xmlns:p="http://schemas.openxmlformats.org/presentationml/2006/main" xmlns:r="http://schemas.openxmlformats.org/officeDocument/2006/relationships">
+  <p:cSld>
+    <p:spTree>
+      <p:nvGrpSpPr>
+        <p:cNvPr id="1" name=""/>
+        <p:cNvGrpSpPr/>
+        <p:nvPr/>
+      </p:nvGrpSpPr>
+      <p:grpSpPr>
+        <a:xfrm>
+          <a:off x="0" y="0"/>
+          <a:ext cx="0" cy="0"/>
+          <a:chOff x="0" y="0"/>
+          <a:chExt cx="0" cy="0"/>
+        </a:xfrm>
+      </p:grpSpPr>
+      <p:sp>
+        <p:nvSpPr>
+          <p:cNvPr id="2" name="Slide Image Placeholder 1"/>
+          <p:cNvSpPr>
+            <a:spLocks noGrp="1"/>
+          </p:cNvSpPr>
+          <p:nvPr>
+            <p:ph type="sldImg" idx="2"/>
+          </p:nvPr>
+        </p:nvSpPr>
+        <p:spPr/>
+      </p:sp>
+      <p:sp>
+        <p:nvSpPr>
+          <p:cNvPr id="3" name="Notes Placeholder 2"/>
+          <p:cNvSpPr>
+            <a:spLocks noGrp="1"/>
+          </p:cNvSpPr>
+          <p:nvPr>
+            <p:ph type="body" idx="3" sz="quarter"/>
+          </p:nvPr>
+        </p:nvSpPr>
+        <p:spPr/>
+        <p:txBody>
+          <a:bodyPr/>
+          <a:lstStyle/>
+          <a:p>
+            <a:r>
+              <a:t>Evidence baseline: commit 655ae1ecc2c9fc0aa80c828fe0303753296f66df. FEI run recorded base commit d1e4ceb3f975fb47d9a8321c47484bb1411f5239 with FEI additions uncommitted.</a:t>
+            </a:r>
+          </a:p>
+          <a:p>
+            <a:r>
+              <a:t>Sources: experiments/cross_dataset_key_pool_summary.csv; experiments/fei_multiexposure/README.md; experiments/mobio_mechanism_controls/results_summary.csv; experiments/mobio_correlation_controls/results_summary.csv.</a:t>
+            </a:r>
+          </a:p>
+          <a:p>
+            <a:r>
+              <a:t>Configuration: configs/attacks/fei_key_pool_boundary.yaml. See reports/figures/README.md for figure captions and docs/ROADMAP.md for pending gates. Diagram symbols are schematic, not biometric examples.</a:t>
+            </a:r>
+          </a:p>
+          <a:p>
+            <a:r>
+              <a:t>New pilot code freeze: d5f4e89. Configuration: configs/attacks/scheme_extension_pilot.yaml. Sources: experiments/scheme_extension_pilot/{results_summary,paired_uncertainty,equivalence_sensitivity,native_utility}.csv. SCface protocol and pilot freeze: 69a93e4; sources under experiments/scface_multiexposure and experiments/scface_scheme_extension_pilot. One-seed CPU pilots, 120-epoch cap; not a controlled ranking against earlier 400-epoch, three-seed studies. See figure_appendix.pdf for all figures, including native matching and uncertainty. Follow-up: experiments/scheme_followup_2026-09-18; 216 endpoints, two identity partitions, three model seeds. Pre-execution source/config hashes: execution_manifest.json; base commit 4352eeb, dirty working tree recorded. Primary sign-flip tests: Holm family 8; native gallery-label permutations: Holm family 12. Independent-pool follow-up: experiments/pool_replication_2026-09-19; 24 cells, 144 fits, 72 prediction-mean evaluations; source snapshots and input hashes recorded. Three-pool intervals are pointwise, not corrected significance tests. Full-text comparison uses the author's thesis section 5.4.</a:t>
+            </a:r>
+          </a:p>
+        </p:txBody>
+      </p:sp>
+      <p:sp>
+        <p:nvSpPr>
+          <p:cNvPr id="4" name="Slide Number Placeholder 3"/>
+          <p:cNvSpPr>
+            <a:spLocks noGrp="1"/>
+          </p:cNvSpPr>
+          <p:nvPr>
+            <p:ph type="sldNum" idx="5" sz="quarter"/>
+          </p:nvPr>
+        </p:nvSpPr>
+        <p:spPr/>
+      </p:sp>
+    </p:spTree>
+  </p:cSld>
+  <p:clrMapOvr>
+    <a:masterClrMapping/>
+  </p:clrMapOvr>
+</p:notes>
+</file>
+
+<file path=ppt/notesSlides/notesSlide14.xml><?xml version="1.0" encoding="utf-8"?>
+<p:notes xmlns:a="http://schemas.openxmlformats.org/drawingml/2006/main" xmlns:p="http://schemas.openxmlformats.org/presentationml/2006/main" xmlns:r="http://schemas.openxmlformats.org/officeDocument/2006/relationships">
+  <p:cSld>
+    <p:spTree>
+      <p:nvGrpSpPr>
+        <p:cNvPr id="1" name=""/>
+        <p:cNvGrpSpPr/>
+        <p:nvPr/>
+      </p:nvGrpSpPr>
+      <p:grpSpPr>
+        <a:xfrm>
+          <a:off x="0" y="0"/>
+          <a:ext cx="0" cy="0"/>
+          <a:chOff x="0" y="0"/>
+          <a:chExt cx="0" cy="0"/>
+        </a:xfrm>
+      </p:grpSpPr>
+      <p:sp>
+        <p:nvSpPr>
+          <p:cNvPr id="2" name="Slide Image Placeholder 1"/>
+          <p:cNvSpPr>
+            <a:spLocks noGrp="1"/>
+          </p:cNvSpPr>
+          <p:nvPr>
+            <p:ph type="sldImg" idx="2"/>
+          </p:nvPr>
+        </p:nvSpPr>
+        <p:spPr/>
+      </p:sp>
+      <p:sp>
+        <p:nvSpPr>
+          <p:cNvPr id="3" name="Notes Placeholder 2"/>
+          <p:cNvSpPr>
+            <a:spLocks noGrp="1"/>
+          </p:cNvSpPr>
+          <p:nvPr>
+            <p:ph type="body" idx="3" sz="quarter"/>
+          </p:nvPr>
+        </p:nvSpPr>
+        <p:spPr/>
+        <p:txBody>
+          <a:bodyPr/>
+          <a:lstStyle/>
+          <a:p>
+            <a:r>
+              <a:t>Evidence baseline: commit 655ae1ecc2c9fc0aa80c828fe0303753296f66df. FEI run recorded base commit d1e4ceb3f975fb47d9a8321c47484bb1411f5239 with FEI additions uncommitted.</a:t>
+            </a:r>
+          </a:p>
+          <a:p>
+            <a:r>
+              <a:t>Sources: experiments/cross_dataset_key_pool_summary.csv; experiments/fei_multiexposure/README.md; experiments/mobio_mechanism_controls/results_summary.csv; experiments/mobio_correlation_controls/results_summary.csv.</a:t>
+            </a:r>
+          </a:p>
+          <a:p>
+            <a:r>
+              <a:t>Configuration: configs/attacks/fei_key_pool_boundary.yaml. See reports/figures/README.md for figure captions and docs/ROADMAP.md for pending gates. Diagram symbols are schematic, not biometric examples.</a:t>
+            </a:r>
+          </a:p>
+          <a:p>
+            <a:r>
+              <a:t>New pilot code freeze: d5f4e89. Configuration: configs/attacks/scheme_extension_pilot.yaml. Sources: experiments/scheme_extension_pilot/{results_summary,paired_uncertainty,equivalence_sensitivity,native_utility}.csv. SCface protocol and pilot freeze: 69a93e4; sources under experiments/scface_multiexposure and experiments/scface_scheme_extension_pilot. One-seed CPU pilots, 120-epoch cap; not a controlled ranking against earlier 400-epoch, three-seed studies. See figure_appendix.pdf for all figures, including native matching and uncertainty. Follow-up: experiments/scheme_followup_2026-09-18; 216 endpoints, two identity partitions, three model seeds. Pre-execution source/config hashes: execution_manifest.json; base commit 4352eeb, dirty working tree recorded. Primary sign-flip tests: Holm family 8; native gallery-label permutations: Holm family 12. Independent-pool follow-up: experiments/pool_replication_2026-09-19; 24 cells, 144 fits, 72 prediction-mean evaluations; source snapshots and input hashes recorded. Three-pool intervals are pointwise, not corrected significance tests. Full-text comparison uses the author's thesis section 5.4.</a:t>
+            </a:r>
+          </a:p>
+        </p:txBody>
+      </p:sp>
+      <p:sp>
+        <p:nvSpPr>
+          <p:cNvPr id="4" name="Slide Number Placeholder 3"/>
+          <p:cNvSpPr>
+            <a:spLocks noGrp="1"/>
+          </p:cNvSpPr>
+          <p:nvPr>
+            <p:ph type="sldNum" idx="5" sz="quarter"/>
+          </p:nvPr>
+        </p:nvSpPr>
+        <p:spPr/>
+      </p:sp>
+    </p:spTree>
+  </p:cSld>
+  <p:clrMapOvr>
+    <a:masterClrMapping/>
+  </p:clrMapOvr>
+</p:notes>
+</file>
+
+<file path=ppt/notesSlides/notesSlide15.xml><?xml version="1.0" encoding="utf-8"?>
 <p:notes xmlns:a="http://schemas.openxmlformats.org/drawingml/2006/main" xmlns:p="http://schemas.openxmlformats.org/presentationml/2006/main" xmlns:r="http://schemas.openxmlformats.org/officeDocument/2006/relationships">
   <p:cSld>
     <p:spTree>
@@ -4548,7 +4806,7 @@
               </a:defRPr>
             </a:pPr>
             <a:r>
-              <a:t>Research review draft | 19 September 2026 | 1/12</a:t>
+              <a:t>Research review draft | 19 September 2026 | 1/15</a:t>
             </a:r>
           </a:p>
         </p:txBody>
@@ -4744,7 +5002,7 @@
               </a:defRPr>
             </a:pPr>
             <a:r>
-              <a:t>MOBIO/FEI: 216 earlier trained endpoints; 144 new fits plus 72 prediction-mean evaluations.</a:t>
+              <a:t>New: 672 MOBIO/SCface endpoints, raw-input retraining and a local stricter-selection audit.</a:t>
             </a:r>
           </a:p>
         </p:txBody>
@@ -4846,7 +5104,7 @@
               </a:defRPr>
             </a:pPr>
             <a:r>
-              <a:t>Research review draft | 19 September 2026 | 10/12</a:t>
+              <a:t>Research review draft | 19 September 2026 | 10/15</a:t>
             </a:r>
           </a:p>
         </p:txBody>
@@ -5014,7 +5272,7 @@
               </a:defRPr>
             </a:pPr>
             <a:r>
-              <a:t>Research review draft | 19 September 2026 | 11/12</a:t>
+              <a:t>Research review draft | 19 September 2026 | 11/15</a:t>
             </a:r>
           </a:p>
         </p:txBody>
@@ -5035,8 +5293,8 @@
         </p:blipFill>
         <p:spPr>
           <a:xfrm>
-            <a:off x="730091" y="960120"/>
-            <a:ext cx="10701337" cy="4892040"/>
+            <a:off x="1870397" y="960120"/>
+            <a:ext cx="8420724" cy="4892040"/>
           </a:xfrm>
           <a:prstGeom prst="rect">
             <a:avLst/>
@@ -5080,7 +5338,7 @@
               </a:defRPr>
             </a:pPr>
             <a:r>
-              <a:t>SCface remains supporting cross-camera evidence, not matched new-scheme confirmation. Missing cells are not zero accuracy.</a:t>
+              <a:t>SCface now has a three-seed/two-partition exposure study. LFW remains historical; missing cells are not zero accuracy.</a:t>
             </a:r>
           </a:p>
         </p:txBody>
@@ -5182,7 +5440,7 @@
               </a:defRPr>
             </a:pPr>
             <a:r>
-              <a:t>Research review draft | 19 September 2026 | 12/12</a:t>
+              <a:t>Research review draft | 19 September 2026 | 12/15</a:t>
             </a:r>
           </a:p>
         </p:txBody>
@@ -5249,6 +5507,510 @@
             </a:pPr>
             <a:r>
               <a:t>Three new pool draws: IoM gains persist; PolyProtect is variable. Input-pooling superiority is not established.</a:t>
+            </a:r>
+          </a:p>
+        </p:txBody>
+      </p:sp>
+    </p:spTree>
+  </p:cSld>
+  <p:clrMapOvr>
+    <a:masterClrMapping/>
+  </p:clrMapOvr>
+</p:sld>
+</file>
+
+<file path=ppt/slides/slide13.xml><?xml version="1.0" encoding="utf-8"?>
+<p:sld xmlns:a="http://schemas.openxmlformats.org/drawingml/2006/main" xmlns:p="http://schemas.openxmlformats.org/presentationml/2006/main" xmlns:r="http://schemas.openxmlformats.org/officeDocument/2006/relationships">
+  <p:cSld>
+    <p:spTree>
+      <p:nvGrpSpPr>
+        <p:cNvPr id="1" name=""/>
+        <p:cNvGrpSpPr/>
+        <p:nvPr/>
+      </p:nvGrpSpPr>
+      <p:grpSpPr/>
+      <p:sp>
+        <p:nvSpPr>
+          <p:cNvPr id="2" name="TextBox 1"/>
+          <p:cNvSpPr txBox="1"/>
+          <p:nvPr/>
+        </p:nvSpPr>
+        <p:spPr>
+          <a:xfrm>
+            <a:off x="548640" y="274320"/>
+            <a:ext cx="11064240" cy="548640"/>
+          </a:xfrm>
+          <a:prstGeom prst="rect">
+            <a:avLst/>
+          </a:prstGeom>
+          <a:noFill/>
+        </p:spPr>
+        <p:txBody>
+          <a:bodyPr wrap="none" lIns="0" rIns="0" tIns="0" bIns="0">
+            <a:spAutoFit/>
+          </a:bodyPr>
+          <a:lstStyle/>
+          <a:p>
+            <a:pPr>
+              <a:lnSpc>
+                <a:spcPct val="140000"/>
+              </a:lnSpc>
+              <a:spcAft>
+                <a:spcPts val="0"/>
+              </a:spcAft>
+              <a:defRPr sz="2500" b="1">
+                <a:solidFill>
+                  <a:srgbClr val="222222"/>
+                </a:solidFill>
+                <a:latin typeface="Times New Roman"/>
+              </a:defRPr>
+            </a:pPr>
+            <a:r>
+              <a:t>Extended exposures: MOBIO and SCface</a:t>
+            </a:r>
+          </a:p>
+        </p:txBody>
+      </p:sp>
+      <p:sp>
+        <p:nvSpPr>
+          <p:cNvPr id="3" name="TextBox 2"/>
+          <p:cNvSpPr txBox="1"/>
+          <p:nvPr/>
+        </p:nvSpPr>
+        <p:spPr>
+          <a:xfrm>
+            <a:off x="548640" y="6464808"/>
+            <a:ext cx="11064240" cy="274320"/>
+          </a:xfrm>
+          <a:prstGeom prst="rect">
+            <a:avLst/>
+          </a:prstGeom>
+          <a:noFill/>
+        </p:spPr>
+        <p:txBody>
+          <a:bodyPr wrap="none" lIns="0" rIns="0" tIns="0" bIns="0">
+            <a:spAutoFit/>
+          </a:bodyPr>
+          <a:lstStyle/>
+          <a:p>
+            <a:pPr>
+              <a:lnSpc>
+                <a:spcPct val="140000"/>
+              </a:lnSpc>
+              <a:spcAft>
+                <a:spcPts val="0"/>
+              </a:spcAft>
+              <a:defRPr sz="1100" b="0">
+                <a:solidFill>
+                  <a:srgbClr val="666666"/>
+                </a:solidFill>
+                <a:latin typeface="Times New Roman"/>
+              </a:defRPr>
+            </a:pPr>
+            <a:r>
+              <a:t>Research review draft | 19 September 2026 | 13/15</a:t>
+            </a:r>
+          </a:p>
+        </p:txBody>
+      </p:sp>
+      <p:pic>
+        <p:nvPicPr>
+          <p:cNvPr id="4" name="Picture 3" descr="fig_extended_exposures.png"/>
+          <p:cNvPicPr>
+            <a:picLocks noChangeAspect="1"/>
+          </p:cNvPicPr>
+          <p:nvPr/>
+        </p:nvPicPr>
+        <p:blipFill>
+          <a:blip r:embed="rId2"/>
+          <a:stretch>
+            <a:fillRect/>
+          </a:stretch>
+        </p:blipFill>
+        <p:spPr>
+          <a:xfrm>
+            <a:off x="1476487" y="960120"/>
+            <a:ext cx="9208545" cy="4892040"/>
+          </a:xfrm>
+          <a:prstGeom prst="rect">
+            <a:avLst/>
+          </a:prstGeom>
+        </p:spPr>
+      </p:pic>
+      <p:sp>
+        <p:nvSpPr>
+          <p:cNvPr id="5" name="TextBox 4"/>
+          <p:cNvSpPr txBox="1"/>
+          <p:nvPr/>
+        </p:nvSpPr>
+        <p:spPr>
+          <a:xfrm>
+            <a:off x="548640" y="6016752"/>
+            <a:ext cx="11064240" cy="365760"/>
+          </a:xfrm>
+          <a:prstGeom prst="rect">
+            <a:avLst/>
+          </a:prstGeom>
+          <a:noFill/>
+        </p:spPr>
+        <p:txBody>
+          <a:bodyPr wrap="none" lIns="0" rIns="0" tIns="0" bIns="0">
+            <a:spAutoFit/>
+          </a:bodyPr>
+          <a:lstStyle/>
+          <a:p>
+            <a:pPr>
+              <a:lnSpc>
+                <a:spcPct val="140000"/>
+              </a:lnSpc>
+              <a:spcAft>
+                <a:spcPts val="0"/>
+              </a:spcAft>
+              <a:defRPr sz="1200" b="0">
+                <a:solidFill>
+                  <a:srgbClr val="222222"/>
+                </a:solidFill>
+                <a:latin typeface="Times New Roman"/>
+              </a:defRPr>
+            </a:pPr>
+            <a:r>
+              <a:t>672 endpoints; eight primary gains pass Holm correction. Larger pools do not guarantee lower observed linkage.</a:t>
+            </a:r>
+          </a:p>
+        </p:txBody>
+      </p:sp>
+    </p:spTree>
+  </p:cSld>
+  <p:clrMapOvr>
+    <a:masterClrMapping/>
+  </p:clrMapOvr>
+</p:sld>
+</file>
+
+<file path=ppt/slides/slide14.xml><?xml version="1.0" encoding="utf-8"?>
+<p:sld xmlns:a="http://schemas.openxmlformats.org/drawingml/2006/main" xmlns:p="http://schemas.openxmlformats.org/presentationml/2006/main" xmlns:r="http://schemas.openxmlformats.org/officeDocument/2006/relationships">
+  <p:cSld>
+    <p:spTree>
+      <p:nvGrpSpPr>
+        <p:cNvPr id="1" name=""/>
+        <p:cNvGrpSpPr/>
+        <p:nvPr/>
+      </p:nvGrpSpPr>
+      <p:grpSpPr/>
+      <p:sp>
+        <p:nvSpPr>
+          <p:cNvPr id="2" name="TextBox 1"/>
+          <p:cNvSpPr txBox="1"/>
+          <p:nvPr/>
+        </p:nvSpPr>
+        <p:spPr>
+          <a:xfrm>
+            <a:off x="548640" y="274320"/>
+            <a:ext cx="11064240" cy="548640"/>
+          </a:xfrm>
+          <a:prstGeom prst="rect">
+            <a:avLst/>
+          </a:prstGeom>
+          <a:noFill/>
+        </p:spPr>
+        <p:txBody>
+          <a:bodyPr wrap="none" lIns="0" rIns="0" tIns="0" bIns="0">
+            <a:spAutoFit/>
+          </a:bodyPr>
+          <a:lstStyle/>
+          <a:p>
+            <a:pPr>
+              <a:lnSpc>
+                <a:spcPct val="140000"/>
+              </a:lnSpc>
+              <a:spcAft>
+                <a:spcPts val="0"/>
+              </a:spcAft>
+              <a:defRPr sz="2500" b="1">
+                <a:solidFill>
+                  <a:srgbClr val="222222"/>
+                </a:solidFill>
+                <a:latin typeface="Times New Roman"/>
+              </a:defRPr>
+            </a:pPr>
+            <a:r>
+              <a:t>Learned attacks on raw embeddings</a:t>
+            </a:r>
+          </a:p>
+        </p:txBody>
+      </p:sp>
+      <p:sp>
+        <p:nvSpPr>
+          <p:cNvPr id="3" name="TextBox 2"/>
+          <p:cNvSpPr txBox="1"/>
+          <p:nvPr/>
+        </p:nvSpPr>
+        <p:spPr>
+          <a:xfrm>
+            <a:off x="548640" y="6464808"/>
+            <a:ext cx="11064240" cy="274320"/>
+          </a:xfrm>
+          <a:prstGeom prst="rect">
+            <a:avLst/>
+          </a:prstGeom>
+          <a:noFill/>
+        </p:spPr>
+        <p:txBody>
+          <a:bodyPr wrap="none" lIns="0" rIns="0" tIns="0" bIns="0">
+            <a:spAutoFit/>
+          </a:bodyPr>
+          <a:lstStyle/>
+          <a:p>
+            <a:pPr>
+              <a:lnSpc>
+                <a:spcPct val="140000"/>
+              </a:lnSpc>
+              <a:spcAft>
+                <a:spcPts val="0"/>
+              </a:spcAft>
+              <a:defRPr sz="1100" b="0">
+                <a:solidFill>
+                  <a:srgbClr val="666666"/>
+                </a:solidFill>
+                <a:latin typeface="Times New Roman"/>
+              </a:defRPr>
+            </a:pPr>
+            <a:r>
+              <a:t>Research review draft | 19 September 2026 | 14/15</a:t>
+            </a:r>
+          </a:p>
+        </p:txBody>
+      </p:sp>
+      <p:pic>
+        <p:nvPicPr>
+          <p:cNvPr id="4" name="Picture 3" descr="fig_raw_learned.png"/>
+          <p:cNvPicPr>
+            <a:picLocks noChangeAspect="1"/>
+          </p:cNvPicPr>
+          <p:nvPr/>
+        </p:nvPicPr>
+        <p:blipFill>
+          <a:blip r:embed="rId2"/>
+          <a:stretch>
+            <a:fillRect/>
+          </a:stretch>
+        </p:blipFill>
+        <p:spPr>
+          <a:xfrm>
+            <a:off x="730091" y="960120"/>
+            <a:ext cx="10701337" cy="4892040"/>
+          </a:xfrm>
+          <a:prstGeom prst="rect">
+            <a:avLst/>
+          </a:prstGeom>
+        </p:spPr>
+      </p:pic>
+      <p:sp>
+        <p:nvSpPr>
+          <p:cNvPr id="5" name="TextBox 4"/>
+          <p:cNvSpPr txBox="1"/>
+          <p:nvPr/>
+        </p:nvSpPr>
+        <p:spPr>
+          <a:xfrm>
+            <a:off x="548640" y="6016752"/>
+            <a:ext cx="11064240" cy="365760"/>
+          </a:xfrm>
+          <a:prstGeom prst="rect">
+            <a:avLst/>
+          </a:prstGeom>
+          <a:noFill/>
+        </p:spPr>
+        <p:txBody>
+          <a:bodyPr wrap="none" lIns="0" rIns="0" tIns="0" bIns="0">
+            <a:spAutoFit/>
+          </a:bodyPr>
+          <a:lstStyle/>
+          <a:p>
+            <a:pPr>
+              <a:lnSpc>
+                <a:spcPct val="140000"/>
+              </a:lnSpc>
+              <a:spcAft>
+                <a:spcPts val="0"/>
+              </a:spcAft>
+              <a:defRPr sz="1200" b="0">
+                <a:solidFill>
+                  <a:srgbClr val="222222"/>
+                </a:solidFill>
+                <a:latin typeface="Times New Roman"/>
+              </a:defRPr>
+            </a:pPr>
+            <a:r>
+              <a:t>Separate descriptive study: bars are seed SD, not confidence intervals. No matched raw-versus-unit causal test.</a:t>
+            </a:r>
+          </a:p>
+        </p:txBody>
+      </p:sp>
+    </p:spTree>
+  </p:cSld>
+  <p:clrMapOvr>
+    <a:masterClrMapping/>
+  </p:clrMapOvr>
+</p:sld>
+</file>
+
+<file path=ppt/slides/slide15.xml><?xml version="1.0" encoding="utf-8"?>
+<p:sld xmlns:a="http://schemas.openxmlformats.org/drawingml/2006/main" xmlns:p="http://schemas.openxmlformats.org/presentationml/2006/main" xmlns:r="http://schemas.openxmlformats.org/officeDocument/2006/relationships">
+  <p:cSld>
+    <p:spTree>
+      <p:nvGrpSpPr>
+        <p:cNvPr id="1" name=""/>
+        <p:cNvGrpSpPr/>
+        <p:nvPr/>
+      </p:nvGrpSpPr>
+      <p:grpSpPr/>
+      <p:sp>
+        <p:nvSpPr>
+          <p:cNvPr id="2" name="TextBox 1"/>
+          <p:cNvSpPr txBox="1"/>
+          <p:nvPr/>
+        </p:nvSpPr>
+        <p:spPr>
+          <a:xfrm>
+            <a:off x="548640" y="274320"/>
+            <a:ext cx="11064240" cy="548640"/>
+          </a:xfrm>
+          <a:prstGeom prst="rect">
+            <a:avLst/>
+          </a:prstGeom>
+          <a:noFill/>
+        </p:spPr>
+        <p:txBody>
+          <a:bodyPr wrap="none" lIns="0" rIns="0" tIns="0" bIns="0">
+            <a:spAutoFit/>
+          </a:bodyPr>
+          <a:lstStyle/>
+          <a:p>
+            <a:pPr>
+              <a:lnSpc>
+                <a:spcPct val="140000"/>
+              </a:lnSpc>
+              <a:spcAft>
+                <a:spcPts val="0"/>
+              </a:spcAft>
+              <a:defRPr sz="2500" b="1">
+                <a:solidFill>
+                  <a:srgbClr val="222222"/>
+                </a:solidFill>
+                <a:latin typeface="Times New Roman"/>
+              </a:defRPr>
+            </a:pPr>
+            <a:r>
+              <a:t>Local stricter PolyProtect selection</a:t>
+            </a:r>
+          </a:p>
+        </p:txBody>
+      </p:sp>
+      <p:sp>
+        <p:nvSpPr>
+          <p:cNvPr id="3" name="TextBox 2"/>
+          <p:cNvSpPr txBox="1"/>
+          <p:nvPr/>
+        </p:nvSpPr>
+        <p:spPr>
+          <a:xfrm>
+            <a:off x="548640" y="6464808"/>
+            <a:ext cx="11064240" cy="274320"/>
+          </a:xfrm>
+          <a:prstGeom prst="rect">
+            <a:avLst/>
+          </a:prstGeom>
+          <a:noFill/>
+        </p:spPr>
+        <p:txBody>
+          <a:bodyPr wrap="none" lIns="0" rIns="0" tIns="0" bIns="0">
+            <a:spAutoFit/>
+          </a:bodyPr>
+          <a:lstStyle/>
+          <a:p>
+            <a:pPr>
+              <a:lnSpc>
+                <a:spcPct val="140000"/>
+              </a:lnSpc>
+              <a:spcAft>
+                <a:spcPts val="0"/>
+              </a:spcAft>
+              <a:defRPr sz="1100" b="0">
+                <a:solidFill>
+                  <a:srgbClr val="666666"/>
+                </a:solidFill>
+                <a:latin typeface="Times New Roman"/>
+              </a:defRPr>
+            </a:pPr>
+            <a:r>
+              <a:t>Research review draft | 19 September 2026 | 15/15</a:t>
+            </a:r>
+          </a:p>
+        </p:txBody>
+      </p:sp>
+      <p:pic>
+        <p:nvPicPr>
+          <p:cNvPr id="4" name="Picture 3" descr="fig_stricter_selection.png"/>
+          <p:cNvPicPr>
+            <a:picLocks noChangeAspect="1"/>
+          </p:cNvPicPr>
+          <p:nvPr/>
+        </p:nvPicPr>
+        <p:blipFill>
+          <a:blip r:embed="rId2"/>
+          <a:stretch>
+            <a:fillRect/>
+          </a:stretch>
+        </p:blipFill>
+        <p:spPr>
+          <a:xfrm>
+            <a:off x="548640" y="1245978"/>
+            <a:ext cx="11064240" cy="4320322"/>
+          </a:xfrm>
+          <a:prstGeom prst="rect">
+            <a:avLst/>
+          </a:prstGeom>
+        </p:spPr>
+      </p:pic>
+      <p:sp>
+        <p:nvSpPr>
+          <p:cNvPr id="5" name="TextBox 4"/>
+          <p:cNvSpPr txBox="1"/>
+          <p:nvPr/>
+        </p:nvSpPr>
+        <p:spPr>
+          <a:xfrm>
+            <a:off x="548640" y="6016752"/>
+            <a:ext cx="11064240" cy="365760"/>
+          </a:xfrm>
+          <a:prstGeom prst="rect">
+            <a:avLst/>
+          </a:prstGeom>
+          <a:noFill/>
+        </p:spPr>
+        <p:txBody>
+          <a:bodyPr wrap="none" lIns="0" rIns="0" tIns="0" bIns="0">
+            <a:spAutoFit/>
+          </a:bodyPr>
+          <a:lstStyle/>
+          <a:p>
+            <a:pPr>
+              <a:lnSpc>
+                <a:spcPct val="140000"/>
+              </a:lnSpc>
+              <a:spcAft>
+                <a:spcPts val="0"/>
+              </a:spcAft>
+              <a:defRPr sz="1200" b="0">
+                <a:solidFill>
+                  <a:srgbClr val="222222"/>
+                </a:solidFill>
+                <a:latin typeface="Times New Roman"/>
+              </a:defRPr>
+            </a:pPr>
+            <a:r>
+              <a:t>No corrected reduction from this local selection rule; not a source-exact refutation of the original policy.</a:t>
             </a:r>
           </a:p>
         </p:txBody>
@@ -5350,7 +6112,7 @@
               </a:defRPr>
             </a:pPr>
             <a:r>
-              <a:t>Research review draft | 19 September 2026 | 2/12</a:t>
+              <a:t>Research review draft | 19 September 2026 | 2/15</a:t>
             </a:r>
           </a:p>
         </p:txBody>
@@ -5518,7 +6280,7 @@
               </a:defRPr>
             </a:pPr>
             <a:r>
-              <a:t>Research review draft | 19 September 2026 | 3/12</a:t>
+              <a:t>Research review draft | 19 September 2026 | 3/15</a:t>
             </a:r>
           </a:p>
         </p:txBody>
@@ -6667,7 +7429,7 @@
               </a:defRPr>
             </a:pPr>
             <a:r>
-              <a:t>Both: MOBIO/FEI three-seed, two-partition follow-up; SCface one-seed pilots.</a:t>
+              <a:t>Both: MOBIO/FEI original follow-up; MOBIO/SCface extended follow-up.</a:t>
             </a:r>
           </a:p>
         </p:txBody>
@@ -6811,7 +7573,7 @@
               </a:defRPr>
             </a:pPr>
             <a:r>
-              <a:t>Research review draft | 19 September 2026 | 4/12</a:t>
+              <a:t>Research review draft | 19 September 2026 | 4/15</a:t>
             </a:r>
           </a:p>
         </p:txBody>
@@ -6979,7 +7741,7 @@
               </a:defRPr>
             </a:pPr>
             <a:r>
-              <a:t>Research review draft | 19 September 2026 | 5/12</a:t>
+              <a:t>Research review draft | 19 September 2026 | 5/15</a:t>
             </a:r>
           </a:p>
         </p:txBody>
@@ -7147,7 +7909,7 @@
               </a:defRPr>
             </a:pPr>
             <a:r>
-              <a:t>Research review draft | 19 September 2026 | 6/12</a:t>
+              <a:t>Research review draft | 19 September 2026 | 6/15</a:t>
             </a:r>
           </a:p>
         </p:txBody>
@@ -7315,7 +8077,7 @@
               </a:defRPr>
             </a:pPr>
             <a:r>
-              <a:t>Research review draft | 19 September 2026 | 7/12</a:t>
+              <a:t>Research review draft | 19 September 2026 | 7/15</a:t>
             </a:r>
           </a:p>
         </p:txBody>
@@ -7483,7 +8245,7 @@
               </a:defRPr>
             </a:pPr>
             <a:r>
-              <a:t>Research review draft | 19 September 2026 | 8/12</a:t>
+              <a:t>Research review draft | 19 September 2026 | 8/15</a:t>
             </a:r>
           </a:p>
         </p:txBody>
@@ -7651,7 +8413,7 @@
               </a:defRPr>
             </a:pPr>
             <a:r>
-              <a:t>Research review draft | 19 September 2026 | 9/12</a:t>
+              <a:t>Research review draft | 19 September 2026 | 9/15</a:t>
             </a:r>
           </a:p>
         </p:txBody>
@@ -7717,7 +8479,7 @@
               </a:defRPr>
             </a:pPr>
             <a:r>
-              <a:t>4,177 raw extractions verified. Separate scalar and SciPy checks reproduce native matching; stronger parameter policies remain untested.</a:t>
+              <a:t>Earlier native audit, not learned retraining. New raw learned and local stricter-selection results appear on slides 14-15.</a:t>
             </a:r>
           </a:p>
         </p:txBody>

</xml_diff>